<commit_message>
Update spotlight deck and presentation scripts
</commit_message>
<xml_diff>
--- a/ppt_build/EmoMoconvq_spotlight.pptx
+++ b/ppt_build/EmoMoconvq_spotlight.pptx
@@ -4,6 +4,9 @@
   <p:sldMasterIdLst>
     <p:sldMasterId id="2147483648" r:id="rId1"/>
   </p:sldMasterIdLst>
+  <p:notesMasterIdLst>
+    <p:notesMasterId r:id="rId11"/>
+  </p:notesMasterIdLst>
   <p:sldIdLst>
     <p:sldId id="256" r:id="rId2"/>
     <p:sldId id="257" r:id="rId3"/>
@@ -15,10 +18,7 @@
     <p:sldId id="263" r:id="rId9"/>
     <p:sldId id="264" r:id="rId10"/>
   </p:sldIdLst>
-  <p:notesMasterIdLst>
-    <p:notesMasterId r:id="rId11"/>
-  </p:notesMasterIdLst>
-  <p:sldSz cx="9144000" cy="5143500"/>
+  <p:sldSz cx="9144000" cy="5143500" type="screen16x9"/>
   <p:notesSz cx="5143500" cy="9144000"/>
   <p:defaultTextStyle>
     <a:lvl1pPr marL="0" algn="l" defTabSz="914400" rtl="0" eaLnBrk="1" latinLnBrk="0" hangingPunct="1">
@@ -112,6 +112,11 @@
       </a:defRPr>
     </a:lvl9pPr>
   </p:defaultTextStyle>
+  <p:extLst>
+    <p:ext uri="{EFAFB233-063F-42B5-8137-9DF3F51BA10A}">
+      <p15:sldGuideLst xmlns:p15="http://schemas.microsoft.com/office/powerpoint/2012/main"/>
+    </p:ext>
+  </p:extLst>
 </p:presentation>
 </file>
 
@@ -137,234 +142,10 @@
           <a:chExt cx="0" cy="0"/>
         </a:xfrm>
       </p:grpSpPr>
-      <p:sp>
-        <p:nvSpPr>
-          <p:cNvPr id="2" name="Header Placeholder 1"/>
-          <p:cNvSpPr>
-            <a:spLocks noGrp="1"/>
-          </p:cNvSpPr>
-          <p:nvPr>
-            <p:ph type="hdr" sz="quarter"/>
-          </p:nvPr>
-        </p:nvSpPr>
-        <p:spPr>
-          <a:xfrm>
-            <a:off x="0" y="0"/>
-            <a:ext cx="2971800" cy="458788"/>
-          </a:xfrm>
-          <a:prstGeom prst="rect">
-            <a:avLst/>
-          </a:prstGeom>
-        </p:spPr>
-        <p:txBody>
-          <a:bodyPr vert="horz" lIns="91440" tIns="45720" rIns="91440" bIns="45720" rtlCol="0"/>
-          <a:lstStyle>
-            <a:lvl1pPr algn="l">
-              <a:defRPr sz="1200"/>
-            </a:lvl1pPr>
-          </a:lstStyle>
-          <a:p>
-            <a:endParaRPr lang="en-US"/>
-          </a:p>
-        </p:txBody>
-      </p:sp>
-      <p:sp>
-        <p:nvSpPr>
-          <p:cNvPr id="3" name="Date Placeholder 2"/>
-          <p:cNvSpPr>
-            <a:spLocks noGrp="1"/>
-          </p:cNvSpPr>
-          <p:nvPr>
-            <p:ph type="dt" idx="1"/>
-          </p:nvPr>
-        </p:nvSpPr>
-        <p:spPr>
-          <a:xfrm>
-            <a:off x="3884613" y="0"/>
-            <a:ext cx="2971800" cy="458788"/>
-          </a:xfrm>
-          <a:prstGeom prst="rect">
-            <a:avLst/>
-          </a:prstGeom>
-        </p:spPr>
-        <p:txBody>
-          <a:bodyPr vert="horz" lIns="91440" tIns="45720" rIns="91440" bIns="45720" rtlCol="0"/>
-          <a:lstStyle>
-            <a:lvl1pPr algn="r">
-              <a:defRPr sz="1200"/>
-            </a:lvl1pPr>
-          </a:lstStyle>
-          <a:p>
-            <a:fld id="{5282F153-3F37-0F45-9E97-73ACFA13230C}" type="datetimeFigureOut">
-              <a:rPr lang="en-US"/>
-              <a:t>7/23/19</a:t>
-            </a:fld>
-            <a:endParaRPr lang="en-US"/>
-          </a:p>
-        </p:txBody>
-      </p:sp>
-      <p:sp>
-        <p:nvSpPr>
-          <p:cNvPr id="4" name="Slide Image Placeholder 3"/>
-          <p:cNvSpPr>
-            <a:spLocks noGrp="1" noRot="1" noChangeAspect="1"/>
-          </p:cNvSpPr>
-          <p:nvPr>
-            <p:ph type="sldImg" idx="2"/>
-          </p:nvPr>
-        </p:nvSpPr>
-        <p:spPr>
-          <a:xfrm>
-            <a:off x="685800" y="1143000"/>
-            <a:ext cx="5486400" cy="3086100"/>
-          </a:xfrm>
-          <a:prstGeom prst="rect">
-            <a:avLst/>
-          </a:prstGeom>
-          <a:noFill/>
-          <a:ln w="12700">
-            <a:solidFill>
-              <a:prstClr val="black"/>
-            </a:solidFill>
-          </a:ln>
-        </p:spPr>
-        <p:txBody>
-          <a:bodyPr vert="horz" lIns="91440" tIns="45720" rIns="91440" bIns="45720" rtlCol="0" anchor="ctr"/>
-          <a:lstStyle/>
-          <a:p>
-            <a:endParaRPr lang="en-US"/>
-          </a:p>
-        </p:txBody>
-      </p:sp>
-      <p:sp>
-        <p:nvSpPr>
-          <p:cNvPr id="5" name="Notes Placeholder 4"/>
-          <p:cNvSpPr>
-            <a:spLocks noGrp="1"/>
-          </p:cNvSpPr>
-          <p:nvPr>
-            <p:ph type="body" sz="quarter" idx="3"/>
-          </p:nvPr>
-        </p:nvSpPr>
-        <p:spPr>
-          <a:xfrm>
-            <a:off x="685800" y="4400550"/>
-            <a:ext cx="5486400" cy="3600450"/>
-          </a:xfrm>
-          <a:prstGeom prst="rect">
-            <a:avLst/>
-          </a:prstGeom>
-        </p:spPr>
-        <p:txBody>
-          <a:bodyPr vert="horz" lIns="91440" tIns="45720" rIns="91440" bIns="45720" rtlCol="0"/>
-          <a:lstStyle/>
-          <a:p>
-            <a:pPr lvl="0"/>
-            <a:r>
-              <a:rPr lang="en-US"/>
-              <a:t>Click to edit Master text styles</a:t>
-            </a:r>
-          </a:p>
-          <a:p>
-            <a:pPr lvl="1"/>
-            <a:r>
-              <a:rPr lang="en-US"/>
-              <a:t>Second level</a:t>
-            </a:r>
-          </a:p>
-          <a:p>
-            <a:pPr lvl="2"/>
-            <a:r>
-              <a:rPr lang="en-US"/>
-              <a:t>Third level</a:t>
-            </a:r>
-          </a:p>
-          <a:p>
-            <a:pPr lvl="3"/>
-            <a:r>
-              <a:rPr lang="en-US"/>
-              <a:t>Fourth level</a:t>
-            </a:r>
-          </a:p>
-          <a:p>
-            <a:pPr lvl="4"/>
-            <a:r>
-              <a:rPr lang="en-US"/>
-              <a:t>Fifth level</a:t>
-            </a:r>
-          </a:p>
-        </p:txBody>
-      </p:sp>
-      <p:sp>
-        <p:nvSpPr>
-          <p:cNvPr id="6" name="Footer Placeholder 5"/>
-          <p:cNvSpPr>
-            <a:spLocks noGrp="1"/>
-          </p:cNvSpPr>
-          <p:nvPr>
-            <p:ph type="ftr" sz="quarter" idx="4"/>
-          </p:nvPr>
-        </p:nvSpPr>
-        <p:spPr>
-          <a:xfrm>
-            <a:off x="0" y="8685213"/>
-            <a:ext cx="2971800" cy="458787"/>
-          </a:xfrm>
-          <a:prstGeom prst="rect">
-            <a:avLst/>
-          </a:prstGeom>
-        </p:spPr>
-        <p:txBody>
-          <a:bodyPr vert="horz" lIns="91440" tIns="45720" rIns="91440" bIns="45720" rtlCol="0" anchor="b"/>
-          <a:lstStyle>
-            <a:lvl1pPr algn="l">
-              <a:defRPr sz="1200"/>
-            </a:lvl1pPr>
-          </a:lstStyle>
-          <a:p>
-            <a:endParaRPr lang="en-US"/>
-          </a:p>
-        </p:txBody>
-      </p:sp>
-      <p:sp>
-        <p:nvSpPr>
-          <p:cNvPr id="7" name="Slide Number Placeholder 6"/>
-          <p:cNvSpPr>
-            <a:spLocks noGrp="1"/>
-          </p:cNvSpPr>
-          <p:nvPr>
-            <p:ph type="sldNum" sz="quarter" idx="5"/>
-          </p:nvPr>
-        </p:nvSpPr>
-        <p:spPr>
-          <a:xfrm>
-            <a:off x="3884613" y="8685213"/>
-            <a:ext cx="2971800" cy="458787"/>
-          </a:xfrm>
-          <a:prstGeom prst="rect">
-            <a:avLst/>
-          </a:prstGeom>
-        </p:spPr>
-        <p:txBody>
-          <a:bodyPr vert="horz" lIns="91440" tIns="45720" rIns="91440" bIns="45720" rtlCol="0" anchor="b"/>
-          <a:lstStyle>
-            <a:lvl1pPr algn="r">
-              <a:defRPr sz="1200"/>
-            </a:lvl1pPr>
-          </a:lstStyle>
-          <a:p>
-            <a:fld id="{CE5E9CC1-C706-0F49-92D6-E571CC5EEA8F}" type="slidenum">
-              <a:rPr lang="en-US"/>
-              <a:t>‹#›</a:t>
-            </a:fld>
-            <a:endParaRPr lang="en-US"/>
-          </a:p>
-        </p:txBody>
-      </p:sp>
     </p:spTree>
     <p:extLst>
       <p:ext uri="{BB962C8B-B14F-4D97-AF65-F5344CB8AC3E}">
-        <p14:creationId xmlns:p14="http://schemas.microsoft.com/office/powerpoint/2010/main" val="1024086991"/>
+        <p14:creationId xmlns:p14="http://schemas.microsoft.com/office/powerpoint/2010/main" val="2572641713"/>
       </p:ext>
     </p:extLst>
   </p:cSld>
@@ -508,10 +289,6 @@
           <a:bodyPr/>
           <a:lstStyle/>
           <a:p>
-            <a:r>
-              <a:rPr lang="en-US" dirty="0"/>
-              <a:t/>
-            </a:r>
             <a:endParaRPr lang="en-US" dirty="0"/>
           </a:p>
         </p:txBody>
@@ -596,10 +373,6 @@
           <a:bodyPr/>
           <a:lstStyle/>
           <a:p>
-            <a:r>
-              <a:rPr lang="en-US" dirty="0"/>
-              <a:t/>
-            </a:r>
             <a:endParaRPr lang="en-US" dirty="0"/>
           </a:p>
         </p:txBody>
@@ -684,10 +457,6 @@
           <a:bodyPr/>
           <a:lstStyle/>
           <a:p>
-            <a:r>
-              <a:rPr lang="en-US" dirty="0"/>
-              <a:t/>
-            </a:r>
             <a:endParaRPr lang="en-US" dirty="0"/>
           </a:p>
         </p:txBody>
@@ -772,10 +541,6 @@
           <a:bodyPr/>
           <a:lstStyle/>
           <a:p>
-            <a:r>
-              <a:rPr lang="en-US" dirty="0"/>
-              <a:t/>
-            </a:r>
             <a:endParaRPr lang="en-US" dirty="0"/>
           </a:p>
         </p:txBody>
@@ -860,10 +625,6 @@
           <a:bodyPr/>
           <a:lstStyle/>
           <a:p>
-            <a:r>
-              <a:rPr lang="en-US" dirty="0"/>
-              <a:t/>
-            </a:r>
             <a:endParaRPr lang="en-US" dirty="0"/>
           </a:p>
         </p:txBody>
@@ -948,10 +709,6 @@
           <a:bodyPr/>
           <a:lstStyle/>
           <a:p>
-            <a:r>
-              <a:rPr lang="en-US" dirty="0"/>
-              <a:t/>
-            </a:r>
             <a:endParaRPr lang="en-US" dirty="0"/>
           </a:p>
         </p:txBody>
@@ -1036,10 +793,6 @@
           <a:bodyPr/>
           <a:lstStyle/>
           <a:p>
-            <a:r>
-              <a:rPr lang="en-US" dirty="0"/>
-              <a:t/>
-            </a:r>
             <a:endParaRPr lang="en-US" dirty="0"/>
           </a:p>
         </p:txBody>
@@ -1124,10 +877,6 @@
           <a:bodyPr/>
           <a:lstStyle/>
           <a:p>
-            <a:r>
-              <a:rPr lang="en-US" dirty="0"/>
-              <a:t/>
-            </a:r>
             <a:endParaRPr lang="en-US" dirty="0"/>
           </a:p>
         </p:txBody>
@@ -1212,10 +961,6 @@
           <a:bodyPr/>
           <a:lstStyle/>
           <a:p>
-            <a:r>
-              <a:rPr lang="en-US" dirty="0"/>
-              <a:t/>
-            </a:r>
             <a:endParaRPr lang="en-US" dirty="0"/>
           </a:p>
         </p:txBody>
@@ -1289,6 +1034,11 @@
 <file path=ppt/slideMasters/slideMaster1.xml><?xml version="1.0" encoding="utf-8"?>
 <p:sldMaster xmlns:a="http://schemas.openxmlformats.org/drawingml/2006/main" xmlns:r="http://schemas.openxmlformats.org/officeDocument/2006/relationships" xmlns:p="http://schemas.openxmlformats.org/presentationml/2006/main">
   <p:cSld>
+    <p:bg>
+      <p:bgRef idx="1001">
+        <a:schemeClr val="bg1"/>
+      </p:bgRef>
+    </p:bg>
     <p:spTree>
       <p:nvGrpSpPr>
         <p:cNvPr id="1" name=""/>
@@ -1571,6 +1321,7 @@
         <a:solidFill>
           <a:srgbClr val="1F2937"/>
         </a:solidFill>
+        <a:effectLst/>
       </p:bgPr>
     </p:bg>
     <p:spTree>
@@ -1608,7 +1359,7 @@
           <a:bodyPr wrap="square" lIns="0" tIns="0" rIns="0" bIns="0" rtlCol="0" anchor="ctr"/>
           <a:lstStyle/>
           <a:p>
-            <a:pPr algn="l" indent="0" marL="0">
+            <a:pPr marL="0" indent="0" algn="l">
               <a:buNone/>
             </a:pPr>
             <a:r>
@@ -1647,7 +1398,7 @@
           <a:bodyPr wrap="square" lIns="0" tIns="0" rIns="0" bIns="0" rtlCol="0" anchor="ctr"/>
           <a:lstStyle/>
           <a:p>
-            <a:pPr algn="l" indent="0" marL="0">
+            <a:pPr marL="0" indent="0" algn="l">
               <a:buNone/>
             </a:pPr>
             <a:r>
@@ -1686,7 +1437,7 @@
           <a:bodyPr wrap="square" lIns="0" tIns="0" rIns="0" bIns="0" rtlCol="0" anchor="ctr"/>
           <a:lstStyle/>
           <a:p>
-            <a:pPr algn="l" indent="0" marL="0">
+            <a:pPr marL="0" indent="0" algn="l">
               <a:buNone/>
             </a:pPr>
             <a:r>
@@ -1726,6 +1477,13 @@
             <a:prstDash val="solid"/>
           </a:ln>
         </p:spPr>
+        <p:txBody>
+          <a:bodyPr/>
+          <a:lstStyle/>
+          <a:p>
+            <a:endParaRPr lang="zh-CN" altLang="en-US"/>
+          </a:p>
+        </p:txBody>
       </p:sp>
       <p:sp>
         <p:nvSpPr>
@@ -1748,9 +1506,20 @@
           <a:bodyPr wrap="square" lIns="0" tIns="0" rIns="0" bIns="0" rtlCol="0" anchor="ctr"/>
           <a:lstStyle/>
           <a:p>
-            <a:pPr algn="l" indent="0" marL="0">
-              <a:buNone/>
-            </a:pPr>
+            <a:pPr marL="0" indent="0" algn="l">
+              <a:buNone/>
+            </a:pPr>
+            <a:r>
+              <a:rPr lang="en-US" sz="1400" i="1" dirty="0" err="1">
+                <a:solidFill>
+                  <a:srgbClr val="9CA3AF"/>
+                </a:solidFill>
+                <a:latin typeface="Calibri" pitchFamily="34" charset="0"/>
+                <a:ea typeface="Calibri" pitchFamily="34" charset="-122"/>
+                <a:cs typeface="Calibri" pitchFamily="34" charset="-120"/>
+              </a:rPr>
+              <a:t>EmoMoconvq</a:t>
+            </a:r>
             <a:r>
               <a:rPr lang="en-US" sz="1400" i="1" dirty="0">
                 <a:solidFill>
@@ -1760,7 +1529,7 @@
                 <a:ea typeface="Calibri" pitchFamily="34" charset="-122"/>
                 <a:cs typeface="Calibri" pitchFamily="34" charset="-120"/>
               </a:rPr>
-              <a:t>EmoMoconvq  —  Spotlight Presentation</a:t>
+              <a:t>  Presentation</a:t>
             </a:r>
             <a:endParaRPr lang="en-US" sz="1400" dirty="0"/>
           </a:p>
@@ -1787,7 +1556,7 @@
           <a:bodyPr wrap="square" lIns="0" tIns="0" rIns="0" bIns="0" rtlCol="0" anchor="ctr"/>
           <a:lstStyle/>
           <a:p>
-            <a:pPr algn="l" indent="0" marL="0">
+            <a:pPr marL="0" indent="0" algn="l">
               <a:buNone/>
             </a:pPr>
             <a:r>
@@ -1826,7 +1595,7 @@
           <a:bodyPr wrap="square" lIns="0" tIns="0" rIns="0" bIns="0" rtlCol="0" anchor="ctr"/>
           <a:lstStyle/>
           <a:p>
-            <a:pPr algn="l" indent="0" marL="0">
+            <a:pPr marL="0" indent="0" algn="l">
               <a:buNone/>
             </a:pPr>
             <a:r>
@@ -1860,6 +1629,7 @@
         <a:solidFill>
           <a:srgbClr val="FFFFFF"/>
         </a:solidFill>
+        <a:effectLst/>
       </p:bgPr>
     </p:bg>
     <p:spTree>
@@ -1897,7 +1667,7 @@
           <a:bodyPr wrap="square" lIns="0" tIns="0" rIns="0" bIns="0" rtlCol="0" anchor="t"/>
           <a:lstStyle/>
           <a:p>
-            <a:pPr algn="l" indent="0" marL="0">
+            <a:pPr marL="0" indent="0" algn="l">
               <a:buNone/>
             </a:pPr>
             <a:r>
@@ -1937,6 +1707,13 @@
             <a:prstDash val="solid"/>
           </a:ln>
         </p:spPr>
+        <p:txBody>
+          <a:bodyPr/>
+          <a:lstStyle/>
+          <a:p>
+            <a:endParaRPr lang="zh-CN" altLang="en-US"/>
+          </a:p>
+        </p:txBody>
       </p:sp>
       <p:sp>
         <p:nvSpPr>
@@ -1959,7 +1736,7 @@
           <a:bodyPr wrap="square" rtlCol="0" anchor="ctr"/>
           <a:lstStyle/>
           <a:p>
-            <a:pPr algn="l" indent="0" marL="0">
+            <a:pPr marL="0" indent="0" algn="l">
               <a:buNone/>
             </a:pPr>
             <a:r>
@@ -2001,6 +1778,13 @@
             <a:prstDash val="solid"/>
           </a:ln>
         </p:spPr>
+        <p:txBody>
+          <a:bodyPr/>
+          <a:lstStyle/>
+          <a:p>
+            <a:endParaRPr lang="zh-CN" altLang="en-US"/>
+          </a:p>
+        </p:txBody>
       </p:sp>
       <p:sp>
         <p:nvSpPr>
@@ -2023,7 +1807,7 @@
           <a:bodyPr wrap="square" lIns="0" tIns="0" rIns="0" bIns="0" rtlCol="0" anchor="ctr"/>
           <a:lstStyle/>
           <a:p>
-            <a:pPr indent="0" marL="0">
+            <a:pPr marL="0" indent="0">
               <a:buNone/>
             </a:pPr>
             <a:r>
@@ -2062,7 +1846,7 @@
           <a:bodyPr wrap="square" rtlCol="0" anchor="ctr"/>
           <a:lstStyle/>
           <a:p>
-            <a:pPr indent="0" marL="0">
+            <a:pPr marL="0" indent="0">
               <a:spcAft>
                 <a:spcPts val="600"/>
               </a:spcAft>
@@ -2082,7 +1866,7 @@
             <a:endParaRPr lang="en-US" sz="1200" dirty="0"/>
           </a:p>
           <a:p>
-            <a:pPr indent="0" marL="0">
+            <a:pPr marL="0" indent="0">
               <a:spcAft>
                 <a:spcPts val="600"/>
               </a:spcAft>
@@ -2127,6 +1911,13 @@
             <a:prstDash val="solid"/>
           </a:ln>
         </p:spPr>
+        <p:txBody>
+          <a:bodyPr/>
+          <a:lstStyle/>
+          <a:p>
+            <a:endParaRPr lang="zh-CN" altLang="en-US"/>
+          </a:p>
+        </p:txBody>
       </p:sp>
       <p:sp>
         <p:nvSpPr>
@@ -2149,7 +1940,7 @@
           <a:bodyPr wrap="square" lIns="0" tIns="0" rIns="0" bIns="0" rtlCol="0" anchor="ctr"/>
           <a:lstStyle/>
           <a:p>
-            <a:pPr indent="0" marL="0">
+            <a:pPr marL="0" indent="0">
               <a:buNone/>
             </a:pPr>
             <a:r>
@@ -2188,7 +1979,7 @@
           <a:bodyPr wrap="square" rtlCol="0" anchor="ctr"/>
           <a:lstStyle/>
           <a:p>
-            <a:pPr indent="0" marL="0">
+            <a:pPr marL="0" indent="0">
               <a:buNone/>
             </a:pPr>
             <a:r>
@@ -2227,7 +2018,7 @@
           <a:bodyPr wrap="square" lIns="0" tIns="0" rIns="0" bIns="0" rtlCol="0" anchor="ctr"/>
           <a:lstStyle/>
           <a:p>
-            <a:pPr algn="l" indent="0" marL="0">
+            <a:pPr marL="0" indent="0" algn="l">
               <a:buNone/>
             </a:pPr>
             <a:r>
@@ -2266,7 +2057,7 @@
           <a:bodyPr wrap="square" rtlCol="0" anchor="ctr"/>
           <a:lstStyle/>
           <a:p>
-            <a:pPr algn="r" indent="0" marL="0">
+            <a:pPr marL="0" indent="0" algn="r">
               <a:buNone/>
             </a:pPr>
             <a:r>
@@ -2300,6 +2091,7 @@
         <a:solidFill>
           <a:srgbClr val="FFFFFF"/>
         </a:solidFill>
+        <a:effectLst/>
       </p:bgPr>
     </p:bg>
     <p:spTree>
@@ -2337,7 +2129,7 @@
           <a:bodyPr wrap="square" lIns="0" tIns="0" rIns="0" bIns="0" rtlCol="0" anchor="t"/>
           <a:lstStyle/>
           <a:p>
-            <a:pPr algn="l" indent="0" marL="0">
+            <a:pPr marL="0" indent="0" algn="l">
               <a:buNone/>
             </a:pPr>
             <a:r>
@@ -2377,6 +2169,13 @@
             <a:prstDash val="solid"/>
           </a:ln>
         </p:spPr>
+        <p:txBody>
+          <a:bodyPr/>
+          <a:lstStyle/>
+          <a:p>
+            <a:endParaRPr lang="zh-CN" altLang="en-US"/>
+          </a:p>
+        </p:txBody>
       </p:sp>
       <p:sp>
         <p:nvSpPr>
@@ -2399,7 +2198,7 @@
           <a:bodyPr wrap="square" lIns="0" tIns="0" rIns="0" bIns="0" rtlCol="0" anchor="t"/>
           <a:lstStyle/>
           <a:p>
-            <a:pPr indent="0" marL="0">
+            <a:pPr marL="0" indent="0">
               <a:buNone/>
             </a:pPr>
             <a:r>
@@ -2438,7 +2237,7 @@
           <a:bodyPr wrap="square" rtlCol="0" anchor="t"/>
           <a:lstStyle/>
           <a:p>
-            <a:pPr indent="0" marL="0">
+            <a:pPr marL="0" indent="0">
               <a:buNone/>
             </a:pPr>
             <a:r>
@@ -2478,6 +2277,13 @@
             <a:prstDash val="solid"/>
           </a:ln>
         </p:spPr>
+        <p:txBody>
+          <a:bodyPr/>
+          <a:lstStyle/>
+          <a:p>
+            <a:endParaRPr lang="zh-CN" altLang="en-US"/>
+          </a:p>
+        </p:txBody>
       </p:sp>
       <p:sp>
         <p:nvSpPr>
@@ -2500,7 +2306,7 @@
           <a:bodyPr wrap="square" lIns="0" tIns="0" rIns="0" bIns="0" rtlCol="0" anchor="t"/>
           <a:lstStyle/>
           <a:p>
-            <a:pPr indent="0" marL="0">
+            <a:pPr marL="0" indent="0">
               <a:buNone/>
             </a:pPr>
             <a:r>
@@ -2539,7 +2345,7 @@
           <a:bodyPr wrap="square" rtlCol="0" anchor="t"/>
           <a:lstStyle/>
           <a:p>
-            <a:pPr indent="0" marL="0">
+            <a:pPr marL="0" indent="0">
               <a:buNone/>
             </a:pPr>
             <a:r>
@@ -2579,6 +2385,13 @@
             <a:prstDash val="solid"/>
           </a:ln>
         </p:spPr>
+        <p:txBody>
+          <a:bodyPr/>
+          <a:lstStyle/>
+          <a:p>
+            <a:endParaRPr lang="zh-CN" altLang="en-US"/>
+          </a:p>
+        </p:txBody>
       </p:sp>
       <p:sp>
         <p:nvSpPr>
@@ -2601,7 +2414,7 @@
           <a:bodyPr wrap="square" lIns="0" tIns="0" rIns="0" bIns="0" rtlCol="0" anchor="t"/>
           <a:lstStyle/>
           <a:p>
-            <a:pPr indent="0" marL="0">
+            <a:pPr marL="0" indent="0">
               <a:buNone/>
             </a:pPr>
             <a:r>
@@ -2640,7 +2453,7 @@
           <a:bodyPr wrap="square" rtlCol="0" anchor="t"/>
           <a:lstStyle/>
           <a:p>
-            <a:pPr indent="0" marL="0">
+            <a:pPr marL="0" indent="0">
               <a:buNone/>
             </a:pPr>
             <a:r>
@@ -2680,6 +2493,13 @@
             <a:prstDash val="solid"/>
           </a:ln>
         </p:spPr>
+        <p:txBody>
+          <a:bodyPr/>
+          <a:lstStyle/>
+          <a:p>
+            <a:endParaRPr lang="zh-CN" altLang="en-US"/>
+          </a:p>
+        </p:txBody>
       </p:sp>
       <p:sp>
         <p:nvSpPr>
@@ -2702,7 +2522,7 @@
           <a:bodyPr wrap="square" lIns="0" tIns="0" rIns="0" bIns="0" rtlCol="0" anchor="t"/>
           <a:lstStyle/>
           <a:p>
-            <a:pPr indent="0" marL="0">
+            <a:pPr marL="0" indent="0">
               <a:buNone/>
             </a:pPr>
             <a:r>
@@ -2741,7 +2561,7 @@
           <a:bodyPr wrap="square" rtlCol="0" anchor="t"/>
           <a:lstStyle/>
           <a:p>
-            <a:pPr indent="0" marL="0">
+            <a:pPr marL="0" indent="0">
               <a:buNone/>
             </a:pPr>
             <a:r>
@@ -2780,7 +2600,7 @@
           <a:bodyPr wrap="square" lIns="0" tIns="0" rIns="0" bIns="0" rtlCol="0" anchor="ctr"/>
           <a:lstStyle/>
           <a:p>
-            <a:pPr algn="l" indent="0" marL="0">
+            <a:pPr marL="0" indent="0" algn="l">
               <a:buNone/>
             </a:pPr>
             <a:r>
@@ -2819,7 +2639,7 @@
           <a:bodyPr wrap="square" rtlCol="0" anchor="ctr"/>
           <a:lstStyle/>
           <a:p>
-            <a:pPr algn="r" indent="0" marL="0">
+            <a:pPr marL="0" indent="0" algn="r">
               <a:buNone/>
             </a:pPr>
             <a:r>
@@ -2853,6 +2673,7 @@
         <a:solidFill>
           <a:srgbClr val="FFFFFF"/>
         </a:solidFill>
+        <a:effectLst/>
       </p:bgPr>
     </p:bg>
     <p:spTree>
@@ -2890,7 +2711,7 @@
           <a:bodyPr wrap="square" lIns="0" tIns="0" rIns="0" bIns="0" rtlCol="0" anchor="t"/>
           <a:lstStyle/>
           <a:p>
-            <a:pPr algn="l" indent="0" marL="0">
+            <a:pPr marL="0" indent="0" algn="l">
               <a:buNone/>
             </a:pPr>
             <a:r>
@@ -2930,6 +2751,13 @@
             <a:prstDash val="solid"/>
           </a:ln>
         </p:spPr>
+        <p:txBody>
+          <a:bodyPr/>
+          <a:lstStyle/>
+          <a:p>
+            <a:endParaRPr lang="zh-CN" altLang="en-US"/>
+          </a:p>
+        </p:txBody>
       </p:sp>
       <p:sp>
         <p:nvSpPr>
@@ -2939,8 +2767,8 @@
         </p:nvSpPr>
         <p:spPr>
           <a:xfrm>
-            <a:off x="457200" y="1097280"/>
-            <a:ext cx="8229600" cy="365760"/>
+            <a:off x="457200" y="1051560"/>
+            <a:ext cx="8229600" cy="320040"/>
           </a:xfrm>
           <a:prstGeom prst="rect">
             <a:avLst/>
@@ -2952,7 +2780,7 @@
           <a:bodyPr wrap="square" lIns="0" tIns="0" rIns="0" bIns="0" rtlCol="0" anchor="ctr"/>
           <a:lstStyle/>
           <a:p>
-            <a:pPr indent="0" marL="0">
+            <a:pPr marL="0" indent="0">
               <a:buNone/>
             </a:pPr>
             <a:r>
@@ -2964,7 +2792,7 @@
                 <a:ea typeface="Calibri" pitchFamily="34" charset="-122"/>
                 <a:cs typeface="Calibri" pitchFamily="34" charset="-120"/>
               </a:rPr>
-              <a:t>Inject emotion into MoConVQ's text feature via a small trainable module; freeze everything else.</a:t>
+              <a:t>EmoMoconvq plugs a tiny trainable emotion branch into MoConVQ's frozen  text → tokens → latent → physics  pipeline.</a:t>
             </a:r>
             <a:endParaRPr lang="en-US" sz="1200" dirty="0"/>
           </a:p>
@@ -2978,8 +2806,157 @@
         </p:nvSpPr>
         <p:spPr>
           <a:xfrm>
-            <a:off x="457200" y="1691640"/>
-            <a:ext cx="1280160" cy="1920240"/>
+            <a:off x="1600200" y="1508760"/>
+            <a:ext cx="1920240" cy="640080"/>
+          </a:xfrm>
+          <a:prstGeom prst="rect">
+            <a:avLst/>
+          </a:prstGeom>
+          <a:solidFill>
+            <a:srgbClr val="EEF2F5"/>
+          </a:solidFill>
+          <a:ln w="19050">
+            <a:solidFill>
+              <a:srgbClr val="5A8A99"/>
+            </a:solidFill>
+            <a:prstDash val="solid"/>
+          </a:ln>
+        </p:spPr>
+        <p:txBody>
+          <a:bodyPr/>
+          <a:lstStyle/>
+          <a:p>
+            <a:endParaRPr lang="zh-CN" altLang="en-US"/>
+          </a:p>
+        </p:txBody>
+      </p:sp>
+      <p:sp>
+        <p:nvSpPr>
+          <p:cNvPr id="6" name="Text 4"/>
+          <p:cNvSpPr/>
+          <p:nvPr/>
+        </p:nvSpPr>
+        <p:spPr>
+          <a:xfrm>
+            <a:off x="1645920" y="1554480"/>
+            <a:ext cx="1828800" cy="256032"/>
+          </a:xfrm>
+          <a:prstGeom prst="rect">
+            <a:avLst/>
+          </a:prstGeom>
+          <a:noFill/>
+          <a:ln/>
+        </p:spPr>
+        <p:txBody>
+          <a:bodyPr wrap="square" lIns="0" tIns="0" rIns="0" bIns="0" rtlCol="0" anchor="ctr"/>
+          <a:lstStyle/>
+          <a:p>
+            <a:pPr marL="0" indent="0" algn="ctr">
+              <a:buNone/>
+            </a:pPr>
+            <a:r>
+              <a:rPr lang="en-US" sz="1100" b="1" dirty="0">
+                <a:solidFill>
+                  <a:srgbClr val="1F2937"/>
+                </a:solidFill>
+                <a:latin typeface="Georgia" pitchFamily="34" charset="0"/>
+                <a:ea typeface="Georgia" pitchFamily="34" charset="-122"/>
+                <a:cs typeface="Georgia" pitchFamily="34" charset="-120"/>
+              </a:rPr>
+              <a:t>Emotion label  c</a:t>
+            </a:r>
+            <a:endParaRPr lang="en-US" sz="1100" dirty="0"/>
+          </a:p>
+        </p:txBody>
+      </p:sp>
+      <p:sp>
+        <p:nvSpPr>
+          <p:cNvPr id="7" name="Text 5"/>
+          <p:cNvSpPr/>
+          <p:nvPr/>
+        </p:nvSpPr>
+        <p:spPr>
+          <a:xfrm>
+            <a:off x="1645920" y="1828800"/>
+            <a:ext cx="1828800" cy="274320"/>
+          </a:xfrm>
+          <a:prstGeom prst="rect">
+            <a:avLst/>
+          </a:prstGeom>
+          <a:noFill/>
+          <a:ln/>
+        </p:spPr>
+        <p:txBody>
+          <a:bodyPr wrap="square" lIns="0" tIns="0" rIns="0" bIns="0" rtlCol="0" anchor="ctr"/>
+          <a:lstStyle/>
+          <a:p>
+            <a:pPr marL="0" indent="0" algn="ctr">
+              <a:buNone/>
+            </a:pPr>
+            <a:r>
+              <a:rPr lang="en-US" sz="1000" i="1" dirty="0">
+                <a:solidFill>
+                  <a:srgbClr val="5A8A99"/>
+                </a:solidFill>
+                <a:latin typeface="Calibri" pitchFamily="34" charset="0"/>
+                <a:ea typeface="Calibri" pitchFamily="34" charset="-122"/>
+                <a:cs typeface="Calibri" pitchFamily="34" charset="-120"/>
+              </a:rPr>
+              <a:t>E_e  (5 × 512)   →   MLP_proj  (→ 1024)</a:t>
+            </a:r>
+            <a:endParaRPr lang="en-US" sz="1000" dirty="0"/>
+          </a:p>
+        </p:txBody>
+      </p:sp>
+      <p:sp>
+        <p:nvSpPr>
+          <p:cNvPr id="8" name="Text 6"/>
+          <p:cNvSpPr/>
+          <p:nvPr/>
+        </p:nvSpPr>
+        <p:spPr>
+          <a:xfrm>
+            <a:off x="182880" y="2830068"/>
+            <a:ext cx="777240" cy="329184"/>
+          </a:xfrm>
+          <a:prstGeom prst="rect">
+            <a:avLst/>
+          </a:prstGeom>
+          <a:noFill/>
+          <a:ln/>
+        </p:spPr>
+        <p:txBody>
+          <a:bodyPr wrap="square" lIns="0" tIns="0" rIns="0" bIns="0" rtlCol="0" anchor="ctr"/>
+          <a:lstStyle/>
+          <a:p>
+            <a:pPr marL="0" indent="0" algn="r">
+              <a:buNone/>
+            </a:pPr>
+            <a:r>
+              <a:rPr lang="en-US" sz="1100" dirty="0">
+                <a:solidFill>
+                  <a:srgbClr val="374151"/>
+                </a:solidFill>
+                <a:latin typeface="Calibri" pitchFamily="34" charset="0"/>
+                <a:ea typeface="Calibri" pitchFamily="34" charset="-122"/>
+                <a:cs typeface="Calibri" pitchFamily="34" charset="-120"/>
+              </a:rPr>
+              <a:t>text  →</a:t>
+            </a:r>
+            <a:endParaRPr lang="en-US" sz="1100" dirty="0"/>
+          </a:p>
+        </p:txBody>
+      </p:sp>
+      <p:sp>
+        <p:nvSpPr>
+          <p:cNvPr id="9" name="Shape 7"/>
+          <p:cNvSpPr/>
+          <p:nvPr/>
+        </p:nvSpPr>
+        <p:spPr>
+          <a:xfrm>
+            <a:off x="1005840" y="2560320"/>
+            <a:ext cx="1280160" cy="868680"/>
           </a:xfrm>
           <a:prstGeom prst="rect">
             <a:avLst/>
@@ -2994,17 +2971,24 @@
             <a:prstDash val="solid"/>
           </a:ln>
         </p:spPr>
-      </p:sp>
-      <p:sp>
-        <p:nvSpPr>
-          <p:cNvPr id="6" name="Text 4"/>
-          <p:cNvSpPr/>
-          <p:nvPr/>
-        </p:nvSpPr>
-        <p:spPr>
-          <a:xfrm>
-            <a:off x="530352" y="2240280"/>
-            <a:ext cx="1133856" cy="411480"/>
+        <p:txBody>
+          <a:bodyPr/>
+          <a:lstStyle/>
+          <a:p>
+            <a:endParaRPr lang="zh-CN" altLang="en-US"/>
+          </a:p>
+        </p:txBody>
+      </p:sp>
+      <p:sp>
+        <p:nvSpPr>
+          <p:cNvPr id="10" name="Text 8"/>
+          <p:cNvSpPr/>
+          <p:nvPr/>
+        </p:nvSpPr>
+        <p:spPr>
+          <a:xfrm>
+            <a:off x="1051560" y="2633472"/>
+            <a:ext cx="1188720" cy="384048"/>
           </a:xfrm>
           <a:prstGeom prst="rect">
             <a:avLst/>
@@ -3016,7 +3000,7 @@
           <a:bodyPr wrap="square" lIns="0" tIns="0" rIns="0" bIns="0" rtlCol="0" anchor="ctr"/>
           <a:lstStyle/>
           <a:p>
-            <a:pPr algn="ctr" indent="0" marL="0">
+            <a:pPr marL="0" indent="0" algn="ctr">
               <a:buNone/>
             </a:pPr>
             <a:r>
@@ -3028,7 +3012,7 @@
                 <a:ea typeface="Georgia" pitchFamily="34" charset="-122"/>
                 <a:cs typeface="Georgia" pitchFamily="34" charset="-120"/>
               </a:rPr>
-              <a:t>Text prompt</a:t>
+              <a:t>T5-large</a:t>
             </a:r>
             <a:endParaRPr lang="en-US" sz="1200" dirty="0"/>
           </a:p>
@@ -3036,14 +3020,14 @@
       </p:sp>
       <p:sp>
         <p:nvSpPr>
-          <p:cNvPr id="7" name="Text 5"/>
-          <p:cNvSpPr/>
-          <p:nvPr/>
-        </p:nvSpPr>
-        <p:spPr>
-          <a:xfrm>
-            <a:off x="530352" y="2651760"/>
-            <a:ext cx="1133856" cy="502920"/>
+          <p:cNvPr id="11" name="Text 9"/>
+          <p:cNvSpPr/>
+          <p:nvPr/>
+        </p:nvSpPr>
+        <p:spPr>
+          <a:xfrm>
+            <a:off x="1051560" y="3017520"/>
+            <a:ext cx="1188720" cy="365760"/>
           </a:xfrm>
           <a:prstGeom prst="rect">
             <a:avLst/>
@@ -3055,11 +3039,11 @@
           <a:bodyPr wrap="square" lIns="0" tIns="0" rIns="0" bIns="0" rtlCol="0" anchor="t"/>
           <a:lstStyle/>
           <a:p>
-            <a:pPr algn="ctr" indent="0" marL="0">
-              <a:buNone/>
-            </a:pPr>
-            <a:r>
-              <a:rPr lang="en-US" sz="950" i="1" dirty="0">
+            <a:pPr marL="0" indent="0" algn="ctr">
+              <a:buNone/>
+            </a:pPr>
+            <a:r>
+              <a:rPr lang="en-US" sz="900" i="1" dirty="0">
                 <a:solidFill>
                   <a:srgbClr val="6B7280"/>
                 </a:solidFill>
@@ -3067,22 +3051,296 @@
                 <a:ea typeface="Calibri" pitchFamily="34" charset="-122"/>
                 <a:cs typeface="Calibri" pitchFamily="34" charset="-120"/>
               </a:rPr>
-              <a:t>(frozen input)</a:t>
-            </a:r>
-            <a:endParaRPr lang="en-US" sz="950" dirty="0"/>
-          </a:p>
-        </p:txBody>
-      </p:sp>
-      <p:sp>
-        <p:nvSpPr>
-          <p:cNvPr id="8" name="Shape 6"/>
-          <p:cNvSpPr/>
-          <p:nvPr/>
-        </p:nvSpPr>
-        <p:spPr>
-          <a:xfrm>
-            <a:off x="1828800" y="1691640"/>
-            <a:ext cx="1280160" cy="1920240"/>
+              <a:t>encoder · frozen</a:t>
+            </a:r>
+            <a:endParaRPr lang="en-US" sz="900" dirty="0"/>
+          </a:p>
+        </p:txBody>
+      </p:sp>
+      <p:sp>
+        <p:nvSpPr>
+          <p:cNvPr id="12" name="Shape 10"/>
+          <p:cNvSpPr/>
+          <p:nvPr/>
+        </p:nvSpPr>
+        <p:spPr>
+          <a:xfrm>
+            <a:off x="2286000" y="2994660"/>
+            <a:ext cx="91440" cy="0"/>
+          </a:xfrm>
+          <a:prstGeom prst="line">
+            <a:avLst/>
+          </a:prstGeom>
+          <a:noFill/>
+          <a:ln w="12700">
+            <a:solidFill>
+              <a:srgbClr val="374151"/>
+            </a:solidFill>
+            <a:prstDash val="solid"/>
+            <a:tailEnd type="triangle"/>
+          </a:ln>
+        </p:spPr>
+        <p:txBody>
+          <a:bodyPr/>
+          <a:lstStyle/>
+          <a:p>
+            <a:endParaRPr lang="zh-CN" altLang="en-US"/>
+          </a:p>
+        </p:txBody>
+      </p:sp>
+      <p:sp>
+        <p:nvSpPr>
+          <p:cNvPr id="13" name="Shape 11"/>
+          <p:cNvSpPr/>
+          <p:nvPr/>
+        </p:nvSpPr>
+        <p:spPr>
+          <a:xfrm>
+            <a:off x="2377440" y="2811780"/>
+            <a:ext cx="365760" cy="365760"/>
+          </a:xfrm>
+          <a:prstGeom prst="ellipse">
+            <a:avLst/>
+          </a:prstGeom>
+          <a:solidFill>
+            <a:srgbClr val="FFFFFF"/>
+          </a:solidFill>
+          <a:ln w="19050">
+            <a:solidFill>
+              <a:srgbClr val="5A8A99"/>
+            </a:solidFill>
+            <a:prstDash val="solid"/>
+          </a:ln>
+        </p:spPr>
+        <p:txBody>
+          <a:bodyPr/>
+          <a:lstStyle/>
+          <a:p>
+            <a:endParaRPr lang="zh-CN" altLang="en-US"/>
+          </a:p>
+        </p:txBody>
+      </p:sp>
+      <p:sp>
+        <p:nvSpPr>
+          <p:cNvPr id="14" name="Text 12"/>
+          <p:cNvSpPr/>
+          <p:nvPr/>
+        </p:nvSpPr>
+        <p:spPr>
+          <a:xfrm>
+            <a:off x="2377440" y="2775204"/>
+            <a:ext cx="365760" cy="365760"/>
+          </a:xfrm>
+          <a:prstGeom prst="rect">
+            <a:avLst/>
+          </a:prstGeom>
+          <a:noFill/>
+          <a:ln/>
+        </p:spPr>
+        <p:txBody>
+          <a:bodyPr wrap="square" lIns="0" tIns="0" rIns="0" bIns="0" rtlCol="0" anchor="ctr"/>
+          <a:lstStyle/>
+          <a:p>
+            <a:pPr marL="0" indent="0" algn="ctr">
+              <a:buNone/>
+            </a:pPr>
+            <a:r>
+              <a:rPr lang="en-US" sz="1800" b="1" dirty="0">
+                <a:solidFill>
+                  <a:srgbClr val="5A8A99"/>
+                </a:solidFill>
+                <a:latin typeface="Georgia" pitchFamily="34" charset="0"/>
+                <a:ea typeface="Georgia" pitchFamily="34" charset="-122"/>
+                <a:cs typeface="Georgia" pitchFamily="34" charset="-120"/>
+              </a:rPr>
+              <a:t>+</a:t>
+            </a:r>
+            <a:endParaRPr lang="en-US" sz="1800" dirty="0"/>
+          </a:p>
+        </p:txBody>
+      </p:sp>
+      <p:sp>
+        <p:nvSpPr>
+          <p:cNvPr id="15" name="Shape 13"/>
+          <p:cNvSpPr/>
+          <p:nvPr/>
+        </p:nvSpPr>
+        <p:spPr>
+          <a:xfrm>
+            <a:off x="2743200" y="2994660"/>
+            <a:ext cx="137160" cy="0"/>
+          </a:xfrm>
+          <a:prstGeom prst="line">
+            <a:avLst/>
+          </a:prstGeom>
+          <a:noFill/>
+          <a:ln w="12700">
+            <a:solidFill>
+              <a:srgbClr val="374151"/>
+            </a:solidFill>
+            <a:prstDash val="solid"/>
+            <a:tailEnd type="triangle"/>
+          </a:ln>
+        </p:spPr>
+        <p:txBody>
+          <a:bodyPr/>
+          <a:lstStyle/>
+          <a:p>
+            <a:endParaRPr lang="zh-CN" altLang="en-US"/>
+          </a:p>
+        </p:txBody>
+      </p:sp>
+      <p:sp>
+        <p:nvSpPr>
+          <p:cNvPr id="16" name="Shape 14"/>
+          <p:cNvSpPr/>
+          <p:nvPr/>
+        </p:nvSpPr>
+        <p:spPr>
+          <a:xfrm>
+            <a:off x="2880360" y="2560320"/>
+            <a:ext cx="1874520" cy="868680"/>
+          </a:xfrm>
+          <a:prstGeom prst="rect">
+            <a:avLst/>
+          </a:prstGeom>
+          <a:solidFill>
+            <a:srgbClr val="EEF2F5"/>
+          </a:solidFill>
+          <a:ln w="19050">
+            <a:solidFill>
+              <a:srgbClr val="5A8A99"/>
+            </a:solidFill>
+            <a:prstDash val="solid"/>
+          </a:ln>
+        </p:spPr>
+        <p:txBody>
+          <a:bodyPr/>
+          <a:lstStyle/>
+          <a:p>
+            <a:endParaRPr lang="zh-CN" altLang="en-US"/>
+          </a:p>
+        </p:txBody>
+      </p:sp>
+      <p:sp>
+        <p:nvSpPr>
+          <p:cNvPr id="17" name="Text 15"/>
+          <p:cNvSpPr/>
+          <p:nvPr/>
+        </p:nvSpPr>
+        <p:spPr>
+          <a:xfrm>
+            <a:off x="2926080" y="2633472"/>
+            <a:ext cx="1783080" cy="384048"/>
+          </a:xfrm>
+          <a:prstGeom prst="rect">
+            <a:avLst/>
+          </a:prstGeom>
+          <a:noFill/>
+          <a:ln/>
+        </p:spPr>
+        <p:txBody>
+          <a:bodyPr wrap="square" lIns="0" tIns="0" rIns="0" bIns="0" rtlCol="0" anchor="ctr"/>
+          <a:lstStyle/>
+          <a:p>
+            <a:pPr marL="0" indent="0" algn="ctr">
+              <a:buNone/>
+            </a:pPr>
+            <a:r>
+              <a:rPr lang="en-US" sz="1200" b="1" dirty="0">
+                <a:solidFill>
+                  <a:srgbClr val="1F2937"/>
+                </a:solidFill>
+                <a:latin typeface="Georgia" pitchFamily="34" charset="0"/>
+                <a:ea typeface="Georgia" pitchFamily="34" charset="-122"/>
+                <a:cs typeface="Georgia" pitchFamily="34" charset="-120"/>
+              </a:rPr>
+              <a:t>T2M-MoConGPT</a:t>
+            </a:r>
+            <a:endParaRPr lang="en-US" sz="1200" dirty="0"/>
+          </a:p>
+        </p:txBody>
+      </p:sp>
+      <p:sp>
+        <p:nvSpPr>
+          <p:cNvPr id="18" name="Text 16"/>
+          <p:cNvSpPr/>
+          <p:nvPr/>
+        </p:nvSpPr>
+        <p:spPr>
+          <a:xfrm>
+            <a:off x="2926080" y="3017520"/>
+            <a:ext cx="1783080" cy="365760"/>
+          </a:xfrm>
+          <a:prstGeom prst="rect">
+            <a:avLst/>
+          </a:prstGeom>
+          <a:noFill/>
+          <a:ln/>
+        </p:spPr>
+        <p:txBody>
+          <a:bodyPr wrap="square" lIns="0" tIns="0" rIns="0" bIns="0" rtlCol="0" anchor="t"/>
+          <a:lstStyle/>
+          <a:p>
+            <a:pPr marL="0" indent="0" algn="ctr">
+              <a:buNone/>
+            </a:pPr>
+            <a:r>
+              <a:rPr lang="en-US" sz="900" i="1" dirty="0">
+                <a:solidFill>
+                  <a:srgbClr val="6B7280"/>
+                </a:solidFill>
+                <a:latin typeface="Calibri" pitchFamily="34" charset="0"/>
+                <a:ea typeface="Calibri" pitchFamily="34" charset="-122"/>
+                <a:cs typeface="Calibri" pitchFamily="34" charset="-120"/>
+              </a:rPr>
+              <a:t>12-layer autoreg. transformer · top-K tuned · emits RQ tokens</a:t>
+            </a:r>
+            <a:endParaRPr lang="en-US" sz="900" dirty="0"/>
+          </a:p>
+        </p:txBody>
+      </p:sp>
+      <p:sp>
+        <p:nvSpPr>
+          <p:cNvPr id="19" name="Shape 17"/>
+          <p:cNvSpPr/>
+          <p:nvPr/>
+        </p:nvSpPr>
+        <p:spPr>
+          <a:xfrm>
+            <a:off x="4754880" y="2994660"/>
+            <a:ext cx="182880" cy="0"/>
+          </a:xfrm>
+          <a:prstGeom prst="line">
+            <a:avLst/>
+          </a:prstGeom>
+          <a:noFill/>
+          <a:ln w="12700">
+            <a:solidFill>
+              <a:srgbClr val="374151"/>
+            </a:solidFill>
+            <a:prstDash val="solid"/>
+            <a:tailEnd type="triangle"/>
+          </a:ln>
+        </p:spPr>
+        <p:txBody>
+          <a:bodyPr/>
+          <a:lstStyle/>
+          <a:p>
+            <a:endParaRPr lang="zh-CN" altLang="en-US"/>
+          </a:p>
+        </p:txBody>
+      </p:sp>
+      <p:sp>
+        <p:nvSpPr>
+          <p:cNvPr id="20" name="Shape 18"/>
+          <p:cNvSpPr/>
+          <p:nvPr/>
+        </p:nvSpPr>
+        <p:spPr>
+          <a:xfrm>
+            <a:off x="4937760" y="2560320"/>
+            <a:ext cx="1508760" cy="868680"/>
           </a:xfrm>
           <a:prstGeom prst="rect">
             <a:avLst/>
@@ -3097,17 +3355,24 @@
             <a:prstDash val="solid"/>
           </a:ln>
         </p:spPr>
-      </p:sp>
-      <p:sp>
-        <p:nvSpPr>
-          <p:cNvPr id="9" name="Text 7"/>
-          <p:cNvSpPr/>
-          <p:nvPr/>
-        </p:nvSpPr>
-        <p:spPr>
-          <a:xfrm>
-            <a:off x="1901952" y="2240280"/>
-            <a:ext cx="1133856" cy="411480"/>
+        <p:txBody>
+          <a:bodyPr/>
+          <a:lstStyle/>
+          <a:p>
+            <a:endParaRPr lang="zh-CN" altLang="en-US"/>
+          </a:p>
+        </p:txBody>
+      </p:sp>
+      <p:sp>
+        <p:nvSpPr>
+          <p:cNvPr id="21" name="Text 19"/>
+          <p:cNvSpPr/>
+          <p:nvPr/>
+        </p:nvSpPr>
+        <p:spPr>
+          <a:xfrm>
+            <a:off x="4983480" y="2633472"/>
+            <a:ext cx="1417320" cy="384048"/>
           </a:xfrm>
           <a:prstGeom prst="rect">
             <a:avLst/>
@@ -3119,7 +3384,7 @@
           <a:bodyPr wrap="square" lIns="0" tIns="0" rIns="0" bIns="0" rtlCol="0" anchor="ctr"/>
           <a:lstStyle/>
           <a:p>
-            <a:pPr algn="ctr" indent="0" marL="0">
+            <a:pPr marL="0" indent="0" algn="ctr">
               <a:buNone/>
             </a:pPr>
             <a:r>
@@ -3131,7 +3396,7 @@
                 <a:ea typeface="Georgia" pitchFamily="34" charset="-122"/>
                 <a:cs typeface="Georgia" pitchFamily="34" charset="-120"/>
               </a:rPr>
-              <a:t>T5-large</a:t>
+              <a:t>ConvVQ decoder</a:t>
             </a:r>
             <a:endParaRPr lang="en-US" sz="1200" dirty="0"/>
           </a:p>
@@ -3139,14 +3404,14 @@
       </p:sp>
       <p:sp>
         <p:nvSpPr>
-          <p:cNvPr id="10" name="Text 8"/>
-          <p:cNvSpPr/>
-          <p:nvPr/>
-        </p:nvSpPr>
-        <p:spPr>
-          <a:xfrm>
-            <a:off x="1901952" y="2651760"/>
-            <a:ext cx="1133856" cy="502920"/>
+          <p:cNvPr id="22" name="Text 20"/>
+          <p:cNvSpPr/>
+          <p:nvPr/>
+        </p:nvSpPr>
+        <p:spPr>
+          <a:xfrm>
+            <a:off x="4983480" y="3017520"/>
+            <a:ext cx="1417320" cy="365760"/>
           </a:xfrm>
           <a:prstGeom prst="rect">
             <a:avLst/>
@@ -3158,11 +3423,11 @@
           <a:bodyPr wrap="square" lIns="0" tIns="0" rIns="0" bIns="0" rtlCol="0" anchor="t"/>
           <a:lstStyle/>
           <a:p>
-            <a:pPr algn="ctr" indent="0" marL="0">
-              <a:buNone/>
-            </a:pPr>
-            <a:r>
-              <a:rPr lang="en-US" sz="950" i="1" dirty="0">
+            <a:pPr marL="0" indent="0" algn="ctr">
+              <a:buNone/>
+            </a:pPr>
+            <a:r>
+              <a:rPr lang="en-US" sz="900" i="1" dirty="0">
                 <a:solidFill>
                   <a:srgbClr val="6B7280"/>
                 </a:solidFill>
@@ -3170,86 +3435,53 @@
                 <a:ea typeface="Calibri" pitchFamily="34" charset="-122"/>
                 <a:cs typeface="Calibri" pitchFamily="34" charset="-120"/>
               </a:rPr>
-              <a:t>frozen</a:t>
-            </a:r>
-            <a:endParaRPr lang="en-US" sz="950" dirty="0"/>
-          </a:p>
-        </p:txBody>
-      </p:sp>
-      <p:sp>
-        <p:nvSpPr>
-          <p:cNvPr id="11" name="Shape 9"/>
-          <p:cNvSpPr/>
-          <p:nvPr/>
-        </p:nvSpPr>
-        <p:spPr>
-          <a:xfrm>
-            <a:off x="3154680" y="2468880"/>
-            <a:ext cx="365760" cy="365760"/>
-          </a:xfrm>
-          <a:prstGeom prst="ellipse">
-            <a:avLst/>
-          </a:prstGeom>
-          <a:solidFill>
-            <a:srgbClr val="FFFFFF"/>
-          </a:solidFill>
-          <a:ln w="19050">
+              <a:t>RQ tokens → motion latent  z</a:t>
+            </a:r>
+            <a:endParaRPr lang="en-US" sz="900" dirty="0"/>
+          </a:p>
+        </p:txBody>
+      </p:sp>
+      <p:sp>
+        <p:nvSpPr>
+          <p:cNvPr id="23" name="Shape 21"/>
+          <p:cNvSpPr/>
+          <p:nvPr/>
+        </p:nvSpPr>
+        <p:spPr>
+          <a:xfrm>
+            <a:off x="6446520" y="2994660"/>
+            <a:ext cx="182880" cy="0"/>
+          </a:xfrm>
+          <a:prstGeom prst="line">
+            <a:avLst/>
+          </a:prstGeom>
+          <a:noFill/>
+          <a:ln w="12700">
             <a:solidFill>
-              <a:srgbClr val="5A8A99"/>
+              <a:srgbClr val="374151"/>
             </a:solidFill>
             <a:prstDash val="solid"/>
+            <a:tailEnd type="triangle"/>
           </a:ln>
         </p:spPr>
-      </p:sp>
-      <p:sp>
-        <p:nvSpPr>
-          <p:cNvPr id="12" name="Text 10"/>
-          <p:cNvSpPr/>
-          <p:nvPr/>
-        </p:nvSpPr>
-        <p:spPr>
-          <a:xfrm>
-            <a:off x="3154680" y="2432304"/>
-            <a:ext cx="365760" cy="365760"/>
-          </a:xfrm>
-          <a:prstGeom prst="rect">
-            <a:avLst/>
-          </a:prstGeom>
-          <a:noFill/>
-          <a:ln/>
-        </p:spPr>
-        <p:txBody>
-          <a:bodyPr wrap="square" lIns="0" tIns="0" rIns="0" bIns="0" rtlCol="0" anchor="ctr"/>
-          <a:lstStyle/>
-          <a:p>
-            <a:pPr algn="ctr" indent="0" marL="0">
-              <a:buNone/>
-            </a:pPr>
-            <a:r>
-              <a:rPr lang="en-US" sz="1800" b="1" dirty="0">
-                <a:solidFill>
-                  <a:srgbClr val="5A8A99"/>
-                </a:solidFill>
-                <a:latin typeface="Georgia" pitchFamily="34" charset="0"/>
-                <a:ea typeface="Georgia" pitchFamily="34" charset="-122"/>
-                <a:cs typeface="Georgia" pitchFamily="34" charset="-120"/>
-              </a:rPr>
-              <a:t>+</a:t>
-            </a:r>
-            <a:endParaRPr lang="en-US" sz="1800" dirty="0"/>
-          </a:p>
-        </p:txBody>
-      </p:sp>
-      <p:sp>
-        <p:nvSpPr>
-          <p:cNvPr id="13" name="Shape 11"/>
-          <p:cNvSpPr/>
-          <p:nvPr/>
-        </p:nvSpPr>
-        <p:spPr>
-          <a:xfrm>
-            <a:off x="3657600" y="1691640"/>
-            <a:ext cx="1554480" cy="1920240"/>
+        <p:txBody>
+          <a:bodyPr/>
+          <a:lstStyle/>
+          <a:p>
+            <a:endParaRPr lang="zh-CN" altLang="en-US"/>
+          </a:p>
+        </p:txBody>
+      </p:sp>
+      <p:sp>
+        <p:nvSpPr>
+          <p:cNvPr id="24" name="Shape 22"/>
+          <p:cNvSpPr/>
+          <p:nvPr/>
+        </p:nvSpPr>
+        <p:spPr>
+          <a:xfrm>
+            <a:off x="6629400" y="2560320"/>
+            <a:ext cx="1737360" cy="868680"/>
           </a:xfrm>
           <a:prstGeom prst="rect">
             <a:avLst/>
@@ -3264,17 +3496,24 @@
             <a:prstDash val="solid"/>
           </a:ln>
         </p:spPr>
-      </p:sp>
-      <p:sp>
-        <p:nvSpPr>
-          <p:cNvPr id="14" name="Text 12"/>
-          <p:cNvSpPr/>
-          <p:nvPr/>
-        </p:nvSpPr>
-        <p:spPr>
-          <a:xfrm>
-            <a:off x="3730752" y="2240280"/>
-            <a:ext cx="1408176" cy="411480"/>
+        <p:txBody>
+          <a:bodyPr/>
+          <a:lstStyle/>
+          <a:p>
+            <a:endParaRPr lang="zh-CN" altLang="en-US"/>
+          </a:p>
+        </p:txBody>
+      </p:sp>
+      <p:sp>
+        <p:nvSpPr>
+          <p:cNvPr id="25" name="Text 23"/>
+          <p:cNvSpPr/>
+          <p:nvPr/>
+        </p:nvSpPr>
+        <p:spPr>
+          <a:xfrm>
+            <a:off x="6675120" y="2633472"/>
+            <a:ext cx="1645920" cy="384048"/>
           </a:xfrm>
           <a:prstGeom prst="rect">
             <a:avLst/>
@@ -3286,7 +3525,7 @@
           <a:bodyPr wrap="square" lIns="0" tIns="0" rIns="0" bIns="0" rtlCol="0" anchor="ctr"/>
           <a:lstStyle/>
           <a:p>
-            <a:pPr algn="ctr" indent="0" marL="0">
+            <a:pPr marL="0" indent="0" algn="ctr">
               <a:buNone/>
             </a:pPr>
             <a:r>
@@ -3298,7 +3537,7 @@
                 <a:ea typeface="Georgia" pitchFamily="34" charset="-122"/>
                 <a:cs typeface="Georgia" pitchFamily="34" charset="-120"/>
               </a:rPr>
-              <a:t>Temporal Transf.</a:t>
+              <a:t>Physics decoder</a:t>
             </a:r>
             <a:endParaRPr lang="en-US" sz="1200" dirty="0"/>
           </a:p>
@@ -3306,14 +3545,14 @@
       </p:sp>
       <p:sp>
         <p:nvSpPr>
-          <p:cNvPr id="15" name="Text 13"/>
-          <p:cNvSpPr/>
-          <p:nvPr/>
-        </p:nvSpPr>
-        <p:spPr>
-          <a:xfrm>
-            <a:off x="3730752" y="2651760"/>
-            <a:ext cx="1408176" cy="502920"/>
+          <p:cNvPr id="26" name="Text 24"/>
+          <p:cNvSpPr/>
+          <p:nvPr/>
+        </p:nvSpPr>
+        <p:spPr>
+          <a:xfrm>
+            <a:off x="6675120" y="3017520"/>
+            <a:ext cx="1645920" cy="365760"/>
           </a:xfrm>
           <a:prstGeom prst="rect">
             <a:avLst/>
@@ -3325,11 +3564,11 @@
           <a:bodyPr wrap="square" lIns="0" tIns="0" rIns="0" bIns="0" rtlCol="0" anchor="t"/>
           <a:lstStyle/>
           <a:p>
-            <a:pPr algn="ctr" indent="0" marL="0">
-              <a:buNone/>
-            </a:pPr>
-            <a:r>
-              <a:rPr lang="en-US" sz="950" i="1" dirty="0">
+            <a:pPr marL="0" indent="0" algn="ctr">
+              <a:buNone/>
+            </a:pPr>
+            <a:r>
+              <a:rPr lang="en-US" sz="900" i="1" dirty="0">
                 <a:solidFill>
                   <a:srgbClr val="6B7280"/>
                 </a:solidFill>
@@ -3337,47 +3576,22 @@
                 <a:ea typeface="Calibri" pitchFamily="34" charset="-122"/>
                 <a:cs typeface="Calibri" pitchFamily="34" charset="-120"/>
               </a:rPr>
-              <a:t>12 layers  •  frozen* or top-K tuned</a:t>
-            </a:r>
-            <a:endParaRPr lang="en-US" sz="950" dirty="0"/>
-          </a:p>
-        </p:txBody>
-      </p:sp>
-      <p:sp>
-        <p:nvSpPr>
-          <p:cNvPr id="16" name="Shape 14"/>
-          <p:cNvSpPr/>
-          <p:nvPr/>
-        </p:nvSpPr>
-        <p:spPr>
-          <a:xfrm>
-            <a:off x="5303520" y="1691640"/>
-            <a:ext cx="1554480" cy="1920240"/>
-          </a:xfrm>
-          <a:prstGeom prst="rect">
-            <a:avLst/>
-          </a:prstGeom>
-          <a:solidFill>
-            <a:srgbClr val="F9FAFB"/>
-          </a:solidFill>
-          <a:ln w="9525">
-            <a:solidFill>
-              <a:srgbClr val="D1D5DB"/>
-            </a:solidFill>
-            <a:prstDash val="solid"/>
-          </a:ln>
-        </p:spPr>
-      </p:sp>
-      <p:sp>
-        <p:nvSpPr>
-          <p:cNvPr id="17" name="Text 15"/>
-          <p:cNvSpPr/>
-          <p:nvPr/>
-        </p:nvSpPr>
-        <p:spPr>
-          <a:xfrm>
-            <a:off x="5376672" y="2240280"/>
-            <a:ext cx="1408176" cy="411480"/>
+              <a:t>MoE tracker + ODE simulator</a:t>
+            </a:r>
+            <a:endParaRPr lang="en-US" sz="900" dirty="0"/>
+          </a:p>
+        </p:txBody>
+      </p:sp>
+      <p:sp>
+        <p:nvSpPr>
+          <p:cNvPr id="27" name="Text 25"/>
+          <p:cNvSpPr/>
+          <p:nvPr/>
+        </p:nvSpPr>
+        <p:spPr>
+          <a:xfrm>
+            <a:off x="8394192" y="2830068"/>
+            <a:ext cx="731520" cy="329184"/>
           </a:xfrm>
           <a:prstGeom prst="rect">
             <a:avLst/>
@@ -3389,176 +3603,34 @@
           <a:bodyPr wrap="square" lIns="0" tIns="0" rIns="0" bIns="0" rtlCol="0" anchor="ctr"/>
           <a:lstStyle/>
           <a:p>
-            <a:pPr algn="ctr" indent="0" marL="0">
-              <a:buNone/>
-            </a:pPr>
-            <a:r>
-              <a:rPr lang="en-US" sz="1200" b="1" dirty="0">
-                <a:solidFill>
-                  <a:srgbClr val="1F2937"/>
-                </a:solidFill>
-                <a:latin typeface="Georgia" pitchFamily="34" charset="0"/>
-                <a:ea typeface="Georgia" pitchFamily="34" charset="-122"/>
-                <a:cs typeface="Georgia" pitchFamily="34" charset="-120"/>
-              </a:rPr>
-              <a:t>Physics Decoder</a:t>
-            </a:r>
-            <a:endParaRPr lang="en-US" sz="1200" dirty="0"/>
-          </a:p>
-        </p:txBody>
-      </p:sp>
-      <p:sp>
-        <p:nvSpPr>
-          <p:cNvPr id="18" name="Text 16"/>
-          <p:cNvSpPr/>
-          <p:nvPr/>
-        </p:nvSpPr>
-        <p:spPr>
-          <a:xfrm>
-            <a:off x="5376672" y="2651760"/>
-            <a:ext cx="1408176" cy="502920"/>
-          </a:xfrm>
-          <a:prstGeom prst="rect">
-            <a:avLst/>
-          </a:prstGeom>
-          <a:noFill/>
-          <a:ln/>
-        </p:spPr>
-        <p:txBody>
-          <a:bodyPr wrap="square" lIns="0" tIns="0" rIns="0" bIns="0" rtlCol="0" anchor="t"/>
-          <a:lstStyle/>
-          <a:p>
-            <a:pPr algn="ctr" indent="0" marL="0">
-              <a:buNone/>
-            </a:pPr>
-            <a:r>
-              <a:rPr lang="en-US" sz="950" i="1" dirty="0">
-                <a:solidFill>
-                  <a:srgbClr val="6B7280"/>
-                </a:solidFill>
-                <a:latin typeface="Calibri" pitchFamily="34" charset="0"/>
-                <a:ea typeface="Calibri" pitchFamily="34" charset="-122"/>
-                <a:cs typeface="Calibri" pitchFamily="34" charset="-120"/>
-              </a:rPr>
-              <a:t>frozen tracker + ODE</a:t>
-            </a:r>
-            <a:endParaRPr lang="en-US" sz="950" dirty="0"/>
-          </a:p>
-        </p:txBody>
-      </p:sp>
-      <p:sp>
-        <p:nvSpPr>
-          <p:cNvPr id="19" name="Shape 17"/>
-          <p:cNvSpPr/>
-          <p:nvPr/>
-        </p:nvSpPr>
-        <p:spPr>
-          <a:xfrm>
-            <a:off x="2743200" y="777240"/>
-            <a:ext cx="1828800" cy="640080"/>
-          </a:xfrm>
-          <a:prstGeom prst="rect">
-            <a:avLst/>
-          </a:prstGeom>
-          <a:solidFill>
-            <a:srgbClr val="EEF2F5"/>
-          </a:solidFill>
-          <a:ln w="19050">
-            <a:solidFill>
-              <a:srgbClr val="5A8A99"/>
-            </a:solidFill>
-            <a:prstDash val="solid"/>
-          </a:ln>
-        </p:spPr>
-      </p:sp>
-      <p:sp>
-        <p:nvSpPr>
-          <p:cNvPr id="20" name="Text 18"/>
-          <p:cNvSpPr/>
-          <p:nvPr/>
-        </p:nvSpPr>
-        <p:spPr>
-          <a:xfrm>
-            <a:off x="2816352" y="822960"/>
-            <a:ext cx="1682496" cy="292608"/>
-          </a:xfrm>
-          <a:prstGeom prst="rect">
-            <a:avLst/>
-          </a:prstGeom>
-          <a:noFill/>
-          <a:ln/>
-        </p:spPr>
-        <p:txBody>
-          <a:bodyPr wrap="square" lIns="0" tIns="0" rIns="0" bIns="0" rtlCol="0" anchor="ctr"/>
-          <a:lstStyle/>
-          <a:p>
-            <a:pPr algn="ctr" indent="0" marL="0">
-              <a:buNone/>
-            </a:pPr>
-            <a:r>
-              <a:rPr lang="en-US" sz="1200" b="1" dirty="0">
-                <a:solidFill>
-                  <a:srgbClr val="1F2937"/>
-                </a:solidFill>
-                <a:latin typeface="Georgia" pitchFamily="34" charset="0"/>
-                <a:ea typeface="Georgia" pitchFamily="34" charset="-122"/>
-                <a:cs typeface="Georgia" pitchFamily="34" charset="-120"/>
-              </a:rPr>
-              <a:t>Emotion label  c</a:t>
-            </a:r>
-            <a:endParaRPr lang="en-US" sz="1200" dirty="0"/>
-          </a:p>
-        </p:txBody>
-      </p:sp>
-      <p:sp>
-        <p:nvSpPr>
-          <p:cNvPr id="21" name="Text 19"/>
-          <p:cNvSpPr/>
-          <p:nvPr/>
-        </p:nvSpPr>
-        <p:spPr>
-          <a:xfrm>
-            <a:off x="2816352" y="1124712"/>
-            <a:ext cx="1682496" cy="274320"/>
-          </a:xfrm>
-          <a:prstGeom prst="rect">
-            <a:avLst/>
-          </a:prstGeom>
-          <a:noFill/>
-          <a:ln/>
-        </p:spPr>
-        <p:txBody>
-          <a:bodyPr wrap="square" lIns="0" tIns="0" rIns="0" bIns="0" rtlCol="0" anchor="ctr"/>
-          <a:lstStyle/>
-          <a:p>
-            <a:pPr algn="ctr" indent="0" marL="0">
-              <a:buNone/>
-            </a:pPr>
-            <a:r>
-              <a:rPr lang="en-US" sz="1000" i="1" dirty="0">
-                <a:solidFill>
-                  <a:srgbClr val="5A8A99"/>
-                </a:solidFill>
-                <a:latin typeface="Calibri" pitchFamily="34" charset="0"/>
-                <a:ea typeface="Calibri" pitchFamily="34" charset="-122"/>
-                <a:cs typeface="Calibri" pitchFamily="34" charset="-120"/>
-              </a:rPr>
-              <a:t>E_e  (5 x 512)   →   MLP_proj  (→ 1024)</a:t>
-            </a:r>
-            <a:endParaRPr lang="en-US" sz="1000" dirty="0"/>
-          </a:p>
-        </p:txBody>
-      </p:sp>
-      <p:sp>
-        <p:nvSpPr>
-          <p:cNvPr id="22" name="Shape 20"/>
-          <p:cNvSpPr/>
-          <p:nvPr/>
-        </p:nvSpPr>
-        <p:spPr>
-          <a:xfrm>
-            <a:off x="3657600" y="1417320"/>
-            <a:ext cx="0" cy="1051560"/>
+            <a:pPr marL="0" indent="0" algn="l">
+              <a:buNone/>
+            </a:pPr>
+            <a:r>
+              <a:rPr lang="en-US" sz="1100" dirty="0">
+                <a:solidFill>
+                  <a:srgbClr val="374151"/>
+                </a:solidFill>
+                <a:latin typeface="Calibri" pitchFamily="34" charset="0"/>
+                <a:ea typeface="Calibri" pitchFamily="34" charset="-122"/>
+                <a:cs typeface="Calibri" pitchFamily="34" charset="-120"/>
+              </a:rPr>
+              <a:t>→  BVH</a:t>
+            </a:r>
+            <a:endParaRPr lang="en-US" sz="1100" dirty="0"/>
+          </a:p>
+        </p:txBody>
+      </p:sp>
+      <p:sp>
+        <p:nvSpPr>
+          <p:cNvPr id="28" name="Shape 26"/>
+          <p:cNvSpPr/>
+          <p:nvPr/>
+        </p:nvSpPr>
+        <p:spPr>
+          <a:xfrm>
+            <a:off x="2560320" y="2148840"/>
+            <a:ext cx="0" cy="662940"/>
           </a:xfrm>
           <a:prstGeom prst="line">
             <a:avLst/>
@@ -3572,16 +3644,139 @@
             <a:tailEnd type="triangle"/>
           </a:ln>
         </p:spPr>
-      </p:sp>
-      <p:sp>
-        <p:nvSpPr>
-          <p:cNvPr id="23" name="Text 21"/>
-          <p:cNvSpPr/>
-          <p:nvPr/>
-        </p:nvSpPr>
-        <p:spPr>
-          <a:xfrm>
-            <a:off x="457200" y="3703320"/>
+        <p:txBody>
+          <a:bodyPr/>
+          <a:lstStyle/>
+          <a:p>
+            <a:endParaRPr lang="zh-CN" altLang="en-US"/>
+          </a:p>
+        </p:txBody>
+      </p:sp>
+      <p:sp>
+        <p:nvSpPr>
+          <p:cNvPr id="29" name="Text 27"/>
+          <p:cNvSpPr/>
+          <p:nvPr/>
+        </p:nvSpPr>
+        <p:spPr>
+          <a:xfrm>
+            <a:off x="457200" y="3584448"/>
+            <a:ext cx="8229600" cy="566928"/>
+          </a:xfrm>
+          <a:prstGeom prst="rect">
+            <a:avLst/>
+          </a:prstGeom>
+          <a:noFill/>
+          <a:ln/>
+        </p:spPr>
+        <p:txBody>
+          <a:bodyPr wrap="square" lIns="0" tIns="0" rIns="0" bIns="0" rtlCol="0" anchor="t"/>
+          <a:lstStyle/>
+          <a:p>
+            <a:pPr marL="0" indent="0">
+              <a:buNone/>
+            </a:pPr>
+            <a:r>
+              <a:rPr lang="en-US" sz="1000" b="1" dirty="0">
+                <a:solidFill>
+                  <a:srgbClr val="1F2937"/>
+                </a:solidFill>
+                <a:latin typeface="Calibri" pitchFamily="34" charset="0"/>
+                <a:ea typeface="Calibri" pitchFamily="34" charset="-122"/>
+                <a:cs typeface="Calibri" pitchFamily="34" charset="-120"/>
+              </a:rPr>
+              <a:t>MoConVQ pipeline (everything outside the teal box is frozen): </a:t>
+            </a:r>
+            <a:r>
+              <a:rPr lang="en-US" sz="1000" dirty="0">
+                <a:solidFill>
+                  <a:srgbClr val="374151"/>
+                </a:solidFill>
+                <a:latin typeface="Calibri" pitchFamily="34" charset="0"/>
+                <a:ea typeface="Calibri" pitchFamily="34" charset="-122"/>
+                <a:cs typeface="Calibri" pitchFamily="34" charset="-120"/>
+              </a:rPr>
+              <a:t>T5 encodes the prompt; </a:t>
+            </a:r>
+            <a:r>
+              <a:rPr lang="en-US" sz="1000" b="1" dirty="0">
+                <a:solidFill>
+                  <a:srgbClr val="5A8A99"/>
+                </a:solidFill>
+                <a:latin typeface="Calibri" pitchFamily="34" charset="0"/>
+                <a:ea typeface="Calibri" pitchFamily="34" charset="-122"/>
+                <a:cs typeface="Calibri" pitchFamily="34" charset="-120"/>
+              </a:rPr>
+              <a:t>T2M-MoConGPT </a:t>
+            </a:r>
+            <a:r>
+              <a:rPr lang="en-US" sz="1000" dirty="0">
+                <a:solidFill>
+                  <a:srgbClr val="374151"/>
+                </a:solidFill>
+                <a:latin typeface="Calibri" pitchFamily="34" charset="0"/>
+                <a:ea typeface="Calibri" pitchFamily="34" charset="-122"/>
+                <a:cs typeface="Calibri" pitchFamily="34" charset="-120"/>
+              </a:rPr>
+              <a:t>autoregressively emits a residual-VQ token sequence; ConvVQ decodes those tokens to a continuous motion latent </a:t>
+            </a:r>
+            <a:r>
+              <a:rPr lang="en-US" sz="1000" i="1" dirty="0">
+                <a:solidFill>
+                  <a:srgbClr val="374151"/>
+                </a:solidFill>
+                <a:latin typeface="Calibri" pitchFamily="34" charset="0"/>
+                <a:ea typeface="Calibri" pitchFamily="34" charset="-122"/>
+                <a:cs typeface="Calibri" pitchFamily="34" charset="-120"/>
+              </a:rPr>
+              <a:t>z</a:t>
+            </a:r>
+            <a:r>
+              <a:rPr lang="en-US" sz="1000" dirty="0">
+                <a:solidFill>
+                  <a:srgbClr val="374151"/>
+                </a:solidFill>
+                <a:latin typeface="Calibri" pitchFamily="34" charset="0"/>
+                <a:ea typeface="Calibri" pitchFamily="34" charset="-122"/>
+                <a:cs typeface="Calibri" pitchFamily="34" charset="-120"/>
+              </a:rPr>
+              <a:t>; the MoE tracking policy then drives an ODE simulator that follows </a:t>
+            </a:r>
+            <a:r>
+              <a:rPr lang="en-US" sz="1000" i="1" dirty="0">
+                <a:solidFill>
+                  <a:srgbClr val="374151"/>
+                </a:solidFill>
+                <a:latin typeface="Calibri" pitchFamily="34" charset="0"/>
+                <a:ea typeface="Calibri" pitchFamily="34" charset="-122"/>
+                <a:cs typeface="Calibri" pitchFamily="34" charset="-120"/>
+              </a:rPr>
+              <a:t>z</a:t>
+            </a:r>
+            <a:r>
+              <a:rPr lang="en-US" sz="1000" dirty="0">
+                <a:solidFill>
+                  <a:srgbClr val="374151"/>
+                </a:solidFill>
+                <a:latin typeface="Calibri" pitchFamily="34" charset="0"/>
+                <a:ea typeface="Calibri" pitchFamily="34" charset="-122"/>
+                <a:cs typeface="Calibri" pitchFamily="34" charset="-120"/>
+              </a:rPr>
+              <a:t> and outputs physically valid BVH motion.</a:t>
+            </a:r>
+            <a:endParaRPr lang="en-US" sz="1000" dirty="0"/>
+          </a:p>
+        </p:txBody>
+      </p:sp>
+      <p:sp>
+        <p:nvSpPr>
+          <p:cNvPr id="30" name="Text 28"/>
+          <p:cNvSpPr/>
+          <p:nvPr/>
+        </p:nvSpPr>
+        <p:spPr>
+          <a:xfrm>
+            <a:off x="457200" y="4251960"/>
             <a:ext cx="8229600" cy="320040"/>
           </a:xfrm>
           <a:prstGeom prst="rect">
@@ -3594,50 +3789,11 @@
           <a:bodyPr wrap="square" lIns="0" tIns="0" rIns="0" bIns="0" rtlCol="0" anchor="ctr"/>
           <a:lstStyle/>
           <a:p>
-            <a:pPr algn="ctr" indent="0" marL="0">
-              <a:buNone/>
-            </a:pPr>
-            <a:r>
-              <a:rPr lang="en-US" sz="1100" i="1" dirty="0">
-                <a:solidFill>
-                  <a:srgbClr val="6B7280"/>
-                </a:solidFill>
-                <a:latin typeface="Calibri" pitchFamily="34" charset="0"/>
-                <a:ea typeface="Calibri" pitchFamily="34" charset="-122"/>
-                <a:cs typeface="Calibri" pitchFamily="34" charset="-120"/>
-              </a:rPr>
-              <a:t>0.8M trainable emotion params  •  upstream MoConVQ source code unmodified</a:t>
-            </a:r>
-            <a:endParaRPr lang="en-US" sz="1100" dirty="0"/>
-          </a:p>
-        </p:txBody>
-      </p:sp>
-      <p:sp>
-        <p:nvSpPr>
-          <p:cNvPr id="24" name="Text 22"/>
-          <p:cNvSpPr/>
-          <p:nvPr/>
-        </p:nvSpPr>
-        <p:spPr>
-          <a:xfrm>
-            <a:off x="457200" y="4069080"/>
-            <a:ext cx="8229600" cy="457200"/>
-          </a:xfrm>
-          <a:prstGeom prst="rect">
-            <a:avLst/>
-          </a:prstGeom>
-          <a:noFill/>
-          <a:ln/>
-        </p:spPr>
-        <p:txBody>
-          <a:bodyPr wrap="square" lIns="0" tIns="0" rIns="0" bIns="0" rtlCol="0" anchor="ctr"/>
-          <a:lstStyle/>
-          <a:p>
-            <a:pPr algn="ctr" indent="0" marL="0">
-              <a:buNone/>
-            </a:pPr>
-            <a:r>
-              <a:rPr lang="en-US" sz="1500" dirty="0">
+            <a:pPr marL="0" indent="0" algn="ctr">
+              <a:buNone/>
+            </a:pPr>
+            <a:r>
+              <a:rPr lang="en-US" sz="1400" dirty="0">
                 <a:solidFill>
                   <a:srgbClr val="1F2937"/>
                 </a:solidFill>
@@ -3645,22 +3801,22 @@
                 <a:ea typeface="Consolas" pitchFamily="34" charset="-122"/>
                 <a:cs typeface="Consolas" pitchFamily="34" charset="-120"/>
               </a:rPr>
-              <a:t>f_cond = f_T5 + MLP_proj( E_e (c) )</a:t>
-            </a:r>
-            <a:endParaRPr lang="en-US" sz="1500" dirty="0"/>
-          </a:p>
-        </p:txBody>
-      </p:sp>
-      <p:sp>
-        <p:nvSpPr>
-          <p:cNvPr id="25" name="Text 23"/>
-          <p:cNvSpPr/>
-          <p:nvPr/>
-        </p:nvSpPr>
-        <p:spPr>
-          <a:xfrm>
-            <a:off x="457200" y="4526280"/>
-            <a:ext cx="8229600" cy="274320"/>
+              <a:t>f_cond  =  f_T5  +  MLP_proj( E_e (c) )</a:t>
+            </a:r>
+            <a:endParaRPr lang="en-US" sz="1400" dirty="0"/>
+          </a:p>
+        </p:txBody>
+      </p:sp>
+      <p:sp>
+        <p:nvSpPr>
+          <p:cNvPr id="31" name="Text 29"/>
+          <p:cNvSpPr/>
+          <p:nvPr/>
+        </p:nvSpPr>
+        <p:spPr>
+          <a:xfrm>
+            <a:off x="457200" y="4572000"/>
+            <a:ext cx="8229600" cy="228600"/>
           </a:xfrm>
           <a:prstGeom prst="rect">
             <a:avLst/>
@@ -3672,11 +3828,11 @@
           <a:bodyPr wrap="square" lIns="0" tIns="0" rIns="0" bIns="0" rtlCol="0" anchor="ctr"/>
           <a:lstStyle/>
           <a:p>
-            <a:pPr algn="ctr" indent="0" marL="0">
-              <a:buNone/>
-            </a:pPr>
-            <a:r>
-              <a:rPr lang="en-US" sz="1050" i="1" dirty="0">
+            <a:pPr marL="0" indent="0" algn="ctr">
+              <a:buNone/>
+            </a:pPr>
+            <a:r>
+              <a:rPr lang="en-US" sz="1000" i="1" dirty="0">
                 <a:solidFill>
                   <a:srgbClr val="6B7280"/>
                 </a:solidFill>
@@ -3684,15 +3840,15 @@
                 <a:ea typeface="Calibri" pitchFamily="34" charset="-122"/>
                 <a:cs typeface="Calibri" pitchFamily="34" charset="-120"/>
               </a:rPr>
-              <a:t>zero-init last linear → at step 0, model = baseline (graceful degradation)</a:t>
-            </a:r>
-            <a:endParaRPr lang="en-US" sz="1050" dirty="0"/>
-          </a:p>
-        </p:txBody>
-      </p:sp>
-      <p:sp>
-        <p:nvSpPr>
-          <p:cNvPr id="26" name="Text 24"/>
+              <a:t>0.8 M trainable emotion params  •  zero-init last linear → step 0 = baseline (graceful degradation)</a:t>
+            </a:r>
+            <a:endParaRPr lang="en-US" sz="1000" dirty="0"/>
+          </a:p>
+        </p:txBody>
+      </p:sp>
+      <p:sp>
+        <p:nvSpPr>
+          <p:cNvPr id="32" name="Text 30"/>
           <p:cNvSpPr/>
           <p:nvPr/>
         </p:nvSpPr>
@@ -3711,7 +3867,7 @@
           <a:bodyPr wrap="square" lIns="0" tIns="0" rIns="0" bIns="0" rtlCol="0" anchor="ctr"/>
           <a:lstStyle/>
           <a:p>
-            <a:pPr algn="l" indent="0" marL="0">
+            <a:pPr marL="0" indent="0" algn="l">
               <a:buNone/>
             </a:pPr>
             <a:r>
@@ -3731,7 +3887,7 @@
       </p:sp>
       <p:sp>
         <p:nvSpPr>
-          <p:cNvPr id="27" name="Text 25"/>
+          <p:cNvPr id="33" name="Text 31"/>
           <p:cNvSpPr/>
           <p:nvPr/>
         </p:nvSpPr>
@@ -3750,7 +3906,7 @@
           <a:bodyPr wrap="square" rtlCol="0" anchor="ctr"/>
           <a:lstStyle/>
           <a:p>
-            <a:pPr algn="r" indent="0" marL="0">
+            <a:pPr marL="0" indent="0" algn="r">
               <a:buNone/>
             </a:pPr>
             <a:r>
@@ -3784,6 +3940,7 @@
         <a:solidFill>
           <a:srgbClr val="FFFFFF"/>
         </a:solidFill>
+        <a:effectLst/>
       </p:bgPr>
     </p:bg>
     <p:spTree>
@@ -3821,7 +3978,7 @@
           <a:bodyPr wrap="square" lIns="0" tIns="0" rIns="0" bIns="0" rtlCol="0" anchor="t"/>
           <a:lstStyle/>
           <a:p>
-            <a:pPr algn="l" indent="0" marL="0">
+            <a:pPr marL="0" indent="0" algn="l">
               <a:buNone/>
             </a:pPr>
             <a:r>
@@ -3861,6 +4018,13 @@
             <a:prstDash val="solid"/>
           </a:ln>
         </p:spPr>
+        <p:txBody>
+          <a:bodyPr/>
+          <a:lstStyle/>
+          <a:p>
+            <a:endParaRPr lang="zh-CN" altLang="en-US"/>
+          </a:p>
+        </p:txBody>
       </p:sp>
       <p:sp>
         <p:nvSpPr>
@@ -3883,7 +4047,7 @@
           <a:bodyPr wrap="square" rtlCol="0" anchor="ctr"/>
           <a:lstStyle/>
           <a:p>
-            <a:pPr indent="0" marL="0">
+            <a:pPr marL="0" indent="0">
               <a:buNone/>
             </a:pPr>
             <a:r>
@@ -3925,6 +4089,13 @@
             <a:prstDash val="solid"/>
           </a:ln>
         </p:spPr>
+        <p:txBody>
+          <a:bodyPr/>
+          <a:lstStyle/>
+          <a:p>
+            <a:endParaRPr lang="zh-CN" altLang="en-US"/>
+          </a:p>
+        </p:txBody>
       </p:sp>
       <p:sp>
         <p:nvSpPr>
@@ -3947,7 +4118,7 @@
           <a:bodyPr wrap="square" lIns="0" tIns="0" rIns="0" bIns="0" rtlCol="0" anchor="ctr"/>
           <a:lstStyle/>
           <a:p>
-            <a:pPr algn="ctr" indent="0" marL="0">
+            <a:pPr marL="0" indent="0" algn="ctr">
               <a:buNone/>
             </a:pPr>
             <a:r>
@@ -3987,6 +4158,13 @@
             <a:prstDash val="solid"/>
           </a:ln>
         </p:spPr>
+        <p:txBody>
+          <a:bodyPr/>
+          <a:lstStyle/>
+          <a:p>
+            <a:endParaRPr lang="zh-CN" altLang="en-US"/>
+          </a:p>
+        </p:txBody>
       </p:sp>
       <p:sp>
         <p:nvSpPr>
@@ -4009,7 +4187,7 @@
           <a:bodyPr wrap="square" lIns="0" tIns="0" rIns="0" bIns="0" rtlCol="0" anchor="ctr"/>
           <a:lstStyle/>
           <a:p>
-            <a:pPr indent="0" marL="0">
+            <a:pPr marL="0" indent="0">
               <a:buNone/>
             </a:pPr>
             <a:r>
@@ -4048,7 +4226,7 @@
           <a:bodyPr wrap="square" lIns="0" tIns="0" rIns="0" bIns="0" rtlCol="0" anchor="ctr"/>
           <a:lstStyle/>
           <a:p>
-            <a:pPr indent="0" marL="0">
+            <a:pPr marL="0" indent="0">
               <a:buNone/>
             </a:pPr>
             <a:r>
@@ -4087,7 +4265,7 @@
           <a:bodyPr wrap="square" lIns="0" tIns="0" rIns="0" bIns="0" rtlCol="0" anchor="ctr"/>
           <a:lstStyle/>
           <a:p>
-            <a:pPr algn="r" indent="0" marL="0">
+            <a:pPr marL="0" indent="0" algn="r">
               <a:buNone/>
             </a:pPr>
             <a:r>
@@ -4126,7 +4304,7 @@
           <a:bodyPr wrap="square" lIns="0" tIns="0" rIns="0" bIns="0" rtlCol="0" anchor="ctr"/>
           <a:lstStyle/>
           <a:p>
-            <a:pPr algn="r" indent="0" marL="0">
+            <a:pPr marL="0" indent="0" algn="r">
               <a:buNone/>
             </a:pPr>
             <a:r>
@@ -4168,6 +4346,13 @@
             <a:prstDash val="solid"/>
           </a:ln>
         </p:spPr>
+        <p:txBody>
+          <a:bodyPr/>
+          <a:lstStyle/>
+          <a:p>
+            <a:endParaRPr lang="zh-CN" altLang="en-US"/>
+          </a:p>
+        </p:txBody>
       </p:sp>
       <p:sp>
         <p:nvSpPr>
@@ -4190,7 +4375,7 @@
           <a:bodyPr wrap="square" lIns="0" tIns="0" rIns="0" bIns="0" rtlCol="0" anchor="ctr"/>
           <a:lstStyle/>
           <a:p>
-            <a:pPr algn="ctr" indent="0" marL="0">
+            <a:pPr marL="0" indent="0" algn="ctr">
               <a:buNone/>
             </a:pPr>
             <a:r>
@@ -4230,6 +4415,13 @@
             <a:prstDash val="solid"/>
           </a:ln>
         </p:spPr>
+        <p:txBody>
+          <a:bodyPr/>
+          <a:lstStyle/>
+          <a:p>
+            <a:endParaRPr lang="zh-CN" altLang="en-US"/>
+          </a:p>
+        </p:txBody>
       </p:sp>
       <p:sp>
         <p:nvSpPr>
@@ -4252,7 +4444,7 @@
           <a:bodyPr wrap="square" lIns="0" tIns="0" rIns="0" bIns="0" rtlCol="0" anchor="ctr"/>
           <a:lstStyle/>
           <a:p>
-            <a:pPr indent="0" marL="0">
+            <a:pPr marL="0" indent="0">
               <a:buNone/>
             </a:pPr>
             <a:r>
@@ -4291,7 +4483,7 @@
           <a:bodyPr wrap="square" lIns="0" tIns="0" rIns="0" bIns="0" rtlCol="0" anchor="ctr"/>
           <a:lstStyle/>
           <a:p>
-            <a:pPr indent="0" marL="0">
+            <a:pPr marL="0" indent="0">
               <a:buNone/>
             </a:pPr>
             <a:r>
@@ -4330,7 +4522,7 @@
           <a:bodyPr wrap="square" lIns="0" tIns="0" rIns="0" bIns="0" rtlCol="0" anchor="ctr"/>
           <a:lstStyle/>
           <a:p>
-            <a:pPr algn="r" indent="0" marL="0">
+            <a:pPr marL="0" indent="0" algn="r">
               <a:buNone/>
             </a:pPr>
             <a:r>
@@ -4369,7 +4561,7 @@
           <a:bodyPr wrap="square" lIns="0" tIns="0" rIns="0" bIns="0" rtlCol="0" anchor="ctr"/>
           <a:lstStyle/>
           <a:p>
-            <a:pPr algn="r" indent="0" marL="0">
+            <a:pPr marL="0" indent="0" algn="r">
               <a:buNone/>
             </a:pPr>
             <a:r>
@@ -4411,6 +4603,13 @@
             <a:prstDash val="solid"/>
           </a:ln>
         </p:spPr>
+        <p:txBody>
+          <a:bodyPr/>
+          <a:lstStyle/>
+          <a:p>
+            <a:endParaRPr lang="zh-CN" altLang="en-US"/>
+          </a:p>
+        </p:txBody>
       </p:sp>
       <p:sp>
         <p:nvSpPr>
@@ -4433,7 +4632,7 @@
           <a:bodyPr wrap="square" lIns="0" tIns="0" rIns="0" bIns="0" rtlCol="0" anchor="ctr"/>
           <a:lstStyle/>
           <a:p>
-            <a:pPr algn="ctr" indent="0" marL="0">
+            <a:pPr marL="0" indent="0" algn="ctr">
               <a:buNone/>
             </a:pPr>
             <a:r>
@@ -4473,6 +4672,13 @@
             <a:prstDash val="solid"/>
           </a:ln>
         </p:spPr>
+        <p:txBody>
+          <a:bodyPr/>
+          <a:lstStyle/>
+          <a:p>
+            <a:endParaRPr lang="zh-CN" altLang="en-US"/>
+          </a:p>
+        </p:txBody>
       </p:sp>
       <p:sp>
         <p:nvSpPr>
@@ -4495,7 +4701,7 @@
           <a:bodyPr wrap="square" lIns="0" tIns="0" rIns="0" bIns="0" rtlCol="0" anchor="ctr"/>
           <a:lstStyle/>
           <a:p>
-            <a:pPr indent="0" marL="0">
+            <a:pPr marL="0" indent="0">
               <a:buNone/>
             </a:pPr>
             <a:r>
@@ -4534,7 +4740,7 @@
           <a:bodyPr wrap="square" lIns="0" tIns="0" rIns="0" bIns="0" rtlCol="0" anchor="ctr"/>
           <a:lstStyle/>
           <a:p>
-            <a:pPr indent="0" marL="0">
+            <a:pPr marL="0" indent="0">
               <a:buNone/>
             </a:pPr>
             <a:r>
@@ -4573,7 +4779,7 @@
           <a:bodyPr wrap="square" lIns="0" tIns="0" rIns="0" bIns="0" rtlCol="0" anchor="ctr"/>
           <a:lstStyle/>
           <a:p>
-            <a:pPr algn="r" indent="0" marL="0">
+            <a:pPr marL="0" indent="0" algn="r">
               <a:buNone/>
             </a:pPr>
             <a:r>
@@ -4612,7 +4818,7 @@
           <a:bodyPr wrap="square" lIns="0" tIns="0" rIns="0" bIns="0" rtlCol="0" anchor="ctr"/>
           <a:lstStyle/>
           <a:p>
-            <a:pPr algn="r" indent="0" marL="0">
+            <a:pPr marL="0" indent="0" algn="r">
               <a:buNone/>
             </a:pPr>
             <a:r>
@@ -4654,6 +4860,13 @@
             <a:prstDash val="solid"/>
           </a:ln>
         </p:spPr>
+        <p:txBody>
+          <a:bodyPr/>
+          <a:lstStyle/>
+          <a:p>
+            <a:endParaRPr lang="zh-CN" altLang="en-US"/>
+          </a:p>
+        </p:txBody>
       </p:sp>
       <p:sp>
         <p:nvSpPr>
@@ -4676,7 +4889,7 @@
           <a:bodyPr wrap="square" lIns="0" tIns="0" rIns="0" bIns="0" rtlCol="0" anchor="ctr"/>
           <a:lstStyle/>
           <a:p>
-            <a:pPr algn="ctr" indent="0" marL="0">
+            <a:pPr marL="0" indent="0" algn="ctr">
               <a:buNone/>
             </a:pPr>
             <a:r>
@@ -4716,6 +4929,13 @@
             <a:prstDash val="solid"/>
           </a:ln>
         </p:spPr>
+        <p:txBody>
+          <a:bodyPr/>
+          <a:lstStyle/>
+          <a:p>
+            <a:endParaRPr lang="zh-CN" altLang="en-US"/>
+          </a:p>
+        </p:txBody>
       </p:sp>
       <p:sp>
         <p:nvSpPr>
@@ -4738,7 +4958,7 @@
           <a:bodyPr wrap="square" lIns="0" tIns="0" rIns="0" bIns="0" rtlCol="0" anchor="ctr"/>
           <a:lstStyle/>
           <a:p>
-            <a:pPr indent="0" marL="0">
+            <a:pPr marL="0" indent="0">
               <a:buNone/>
             </a:pPr>
             <a:r>
@@ -4777,7 +4997,7 @@
           <a:bodyPr wrap="square" lIns="0" tIns="0" rIns="0" bIns="0" rtlCol="0" anchor="ctr"/>
           <a:lstStyle/>
           <a:p>
-            <a:pPr indent="0" marL="0">
+            <a:pPr marL="0" indent="0">
               <a:buNone/>
             </a:pPr>
             <a:r>
@@ -4816,7 +5036,7 @@
           <a:bodyPr wrap="square" lIns="0" tIns="0" rIns="0" bIns="0" rtlCol="0" anchor="ctr"/>
           <a:lstStyle/>
           <a:p>
-            <a:pPr algn="r" indent="0" marL="0">
+            <a:pPr marL="0" indent="0" algn="r">
               <a:buNone/>
             </a:pPr>
             <a:r>
@@ -4855,7 +5075,7 @@
           <a:bodyPr wrap="square" lIns="0" tIns="0" rIns="0" bIns="0" rtlCol="0" anchor="ctr"/>
           <a:lstStyle/>
           <a:p>
-            <a:pPr algn="r" indent="0" marL="0">
+            <a:pPr marL="0" indent="0" algn="r">
               <a:buNone/>
             </a:pPr>
             <a:r>
@@ -4894,7 +5114,7 @@
           <a:bodyPr wrap="square" lIns="0" tIns="0" rIns="0" bIns="0" rtlCol="0" anchor="ctr"/>
           <a:lstStyle/>
           <a:p>
-            <a:pPr algn="l" indent="0" marL="0">
+            <a:pPr marL="0" indent="0" algn="l">
               <a:buNone/>
             </a:pPr>
             <a:r>
@@ -4933,7 +5153,7 @@
           <a:bodyPr wrap="square" rtlCol="0" anchor="ctr"/>
           <a:lstStyle/>
           <a:p>
-            <a:pPr algn="r" indent="0" marL="0">
+            <a:pPr marL="0" indent="0" algn="r">
               <a:buNone/>
             </a:pPr>
             <a:r>
@@ -4967,6 +5187,7 @@
         <a:solidFill>
           <a:srgbClr val="FFFFFF"/>
         </a:solidFill>
+        <a:effectLst/>
       </p:bgPr>
     </p:bg>
     <p:spTree>
@@ -5004,7 +5225,7 @@
           <a:bodyPr wrap="square" lIns="0" tIns="0" rIns="0" bIns="0" rtlCol="0" anchor="t"/>
           <a:lstStyle/>
           <a:p>
-            <a:pPr algn="l" indent="0" marL="0">
+            <a:pPr marL="0" indent="0" algn="l">
               <a:buNone/>
             </a:pPr>
             <a:r>
@@ -5044,6 +5265,13 @@
             <a:prstDash val="solid"/>
           </a:ln>
         </p:spPr>
+        <p:txBody>
+          <a:bodyPr/>
+          <a:lstStyle/>
+          <a:p>
+            <a:endParaRPr lang="zh-CN" altLang="en-US"/>
+          </a:p>
+        </p:txBody>
       </p:sp>
       <p:sp>
         <p:nvSpPr>
@@ -5066,7 +5294,7 @@
           <a:bodyPr wrap="square" rtlCol="0" anchor="ctr"/>
           <a:lstStyle/>
           <a:p>
-            <a:pPr indent="0" marL="0">
+            <a:pPr marL="0" indent="0">
               <a:buNone/>
             </a:pPr>
             <a:r>
@@ -5108,6 +5336,13 @@
             <a:prstDash val="solid"/>
           </a:ln>
         </p:spPr>
+        <p:txBody>
+          <a:bodyPr/>
+          <a:lstStyle/>
+          <a:p>
+            <a:endParaRPr lang="zh-CN" altLang="en-US"/>
+          </a:p>
+        </p:txBody>
       </p:sp>
       <p:sp>
         <p:nvSpPr>
@@ -5130,7 +5365,7 @@
           <a:bodyPr wrap="square" lIns="0" tIns="0" rIns="0" bIns="0" rtlCol="0" anchor="ctr"/>
           <a:lstStyle/>
           <a:p>
-            <a:pPr indent="0" marL="0">
+            <a:pPr marL="0" indent="0">
               <a:buNone/>
             </a:pPr>
             <a:r>
@@ -5169,7 +5404,7 @@
           <a:bodyPr wrap="square" lIns="0" tIns="0" rIns="0" bIns="0" rtlCol="0" anchor="ctr"/>
           <a:lstStyle/>
           <a:p>
-            <a:pPr indent="0" marL="0">
+            <a:pPr marL="0" indent="0">
               <a:buNone/>
             </a:pPr>
             <a:r>
@@ -5186,7 +5421,7 @@
             <a:endParaRPr lang="en-US" sz="1100" dirty="0"/>
           </a:p>
           <a:p>
-            <a:pPr indent="0" marL="0">
+            <a:pPr marL="0" indent="0">
               <a:buNone/>
             </a:pPr>
             <a:r>
@@ -5228,6 +5463,13 @@
             <a:prstDash val="solid"/>
           </a:ln>
         </p:spPr>
+        <p:txBody>
+          <a:bodyPr/>
+          <a:lstStyle/>
+          <a:p>
+            <a:endParaRPr lang="zh-CN" altLang="en-US"/>
+          </a:p>
+        </p:txBody>
       </p:sp>
       <p:sp>
         <p:nvSpPr>
@@ -5250,7 +5492,7 @@
           <a:bodyPr wrap="square" lIns="0" tIns="0" rIns="0" bIns="0" rtlCol="0" anchor="ctr"/>
           <a:lstStyle/>
           <a:p>
-            <a:pPr indent="0" marL="0">
+            <a:pPr marL="0" indent="0">
               <a:buNone/>
             </a:pPr>
             <a:r>
@@ -5289,7 +5531,7 @@
           <a:bodyPr wrap="square" lIns="0" tIns="0" rIns="0" bIns="0" rtlCol="0" anchor="ctr"/>
           <a:lstStyle/>
           <a:p>
-            <a:pPr indent="0" marL="0">
+            <a:pPr marL="0" indent="0">
               <a:buNone/>
             </a:pPr>
             <a:r>
@@ -5306,7 +5548,7 @@
             <a:endParaRPr lang="en-US" sz="1100" dirty="0"/>
           </a:p>
           <a:p>
-            <a:pPr indent="0" marL="0">
+            <a:pPr marL="0" indent="0">
               <a:buNone/>
             </a:pPr>
             <a:r>
@@ -5326,14 +5568,14 @@
       </p:sp>
       <p:pic>
         <p:nvPicPr>
-          <p:cNvPr id="11" name="Image 0" descr="D:\My_Study\sophomore\Robotics\EmoMoconvq\ppt_build\fig_progression.png">    </p:cNvPr>
+          <p:cNvPr id="11" name="Image 0" descr="D:\My_Study\sophomore\Robotics\EmoMoconvq\ppt_build\fig_progression.png"/>
           <p:cNvPicPr>
             <a:picLocks noChangeAspect="1"/>
           </p:cNvPicPr>
           <p:nvPr/>
         </p:nvPicPr>
         <p:blipFill>
-          <a:blip r:embed="rId1"/>
+          <a:blip r:embed="rId3"/>
           <a:stretch>
             <a:fillRect/>
           </a:stretch>
@@ -5369,7 +5611,7 @@
           <a:bodyPr wrap="square" rtlCol="0" anchor="ctr"/>
           <a:lstStyle/>
           <a:p>
-            <a:pPr algn="l" indent="0" marL="0">
+            <a:pPr marL="0" indent="0" algn="l">
               <a:buNone/>
             </a:pPr>
             <a:r>
@@ -5408,7 +5650,7 @@
           <a:bodyPr wrap="square" lIns="0" tIns="0" rIns="0" bIns="0" rtlCol="0" anchor="ctr"/>
           <a:lstStyle/>
           <a:p>
-            <a:pPr algn="l" indent="0" marL="0">
+            <a:pPr marL="0" indent="0" algn="l">
               <a:buNone/>
             </a:pPr>
             <a:r>
@@ -5447,7 +5689,7 @@
           <a:bodyPr wrap="square" rtlCol="0" anchor="ctr"/>
           <a:lstStyle/>
           <a:p>
-            <a:pPr algn="r" indent="0" marL="0">
+            <a:pPr marL="0" indent="0" algn="r">
               <a:buNone/>
             </a:pPr>
             <a:r>
@@ -5481,6 +5723,7 @@
         <a:solidFill>
           <a:srgbClr val="FFFFFF"/>
         </a:solidFill>
+        <a:effectLst/>
       </p:bgPr>
     </p:bg>
     <p:spTree>
@@ -5518,7 +5761,7 @@
           <a:bodyPr wrap="square" lIns="0" tIns="0" rIns="0" bIns="0" rtlCol="0" anchor="t"/>
           <a:lstStyle/>
           <a:p>
-            <a:pPr algn="l" indent="0" marL="0">
+            <a:pPr marL="0" indent="0" algn="l">
               <a:buNone/>
             </a:pPr>
             <a:r>
@@ -5558,6 +5801,13 @@
             <a:prstDash val="solid"/>
           </a:ln>
         </p:spPr>
+        <p:txBody>
+          <a:bodyPr/>
+          <a:lstStyle/>
+          <a:p>
+            <a:endParaRPr lang="zh-CN" altLang="en-US"/>
+          </a:p>
+        </p:txBody>
       </p:sp>
       <p:sp>
         <p:nvSpPr>
@@ -5580,7 +5830,7 @@
           <a:bodyPr wrap="square" rtlCol="0" anchor="ctr"/>
           <a:lstStyle/>
           <a:p>
-            <a:pPr indent="0" marL="0">
+            <a:pPr marL="0" indent="0">
               <a:buNone/>
             </a:pPr>
             <a:r>
@@ -5619,7 +5869,7 @@
           <a:bodyPr wrap="square" rtlCol="0" anchor="ctr"/>
           <a:lstStyle/>
           <a:p>
-            <a:pPr indent="0" marL="0">
+            <a:pPr marL="0" indent="0">
               <a:buNone/>
             </a:pPr>
             <a:r>
@@ -5639,14 +5889,14 @@
       </p:sp>
       <p:pic>
         <p:nvPicPr>
-          <p:cNvPr id="6" name="Image 0" descr="D:\My_Study\sophomore\Robotics\EmoMoconvq\ppt_build\fig_kinematic_anova.png">    </p:cNvPr>
+          <p:cNvPr id="6" name="Image 0" descr="D:\My_Study\sophomore\Robotics\EmoMoconvq\ppt_build\fig_kinematic_anova.png"/>
           <p:cNvPicPr>
             <a:picLocks noChangeAspect="1"/>
           </p:cNvPicPr>
           <p:nvPr/>
         </p:nvPicPr>
         <p:blipFill>
-          <a:blip r:embed="rId1"/>
+          <a:blip r:embed="rId3"/>
           <a:stretch>
             <a:fillRect/>
           </a:stretch>
@@ -5685,6 +5935,13 @@
             <a:prstDash val="solid"/>
           </a:ln>
         </p:spPr>
+        <p:txBody>
+          <a:bodyPr/>
+          <a:lstStyle/>
+          <a:p>
+            <a:endParaRPr lang="zh-CN" altLang="en-US"/>
+          </a:p>
+        </p:txBody>
       </p:sp>
       <p:sp>
         <p:nvSpPr>
@@ -5707,7 +5964,7 @@
           <a:bodyPr wrap="square" lIns="0" tIns="0" rIns="0" bIns="0" rtlCol="0" anchor="ctr"/>
           <a:lstStyle/>
           <a:p>
-            <a:pPr indent="0" marL="0">
+            <a:pPr marL="0" indent="0">
               <a:buNone/>
             </a:pPr>
             <a:r>
@@ -5746,7 +6003,7 @@
           <a:bodyPr wrap="square" lIns="0" tIns="0" rIns="0" bIns="0" rtlCol="0" anchor="ctr"/>
           <a:lstStyle/>
           <a:p>
-            <a:pPr indent="0" marL="0">
+            <a:pPr marL="0" indent="0">
               <a:buNone/>
             </a:pPr>
             <a:r>
@@ -5785,7 +6042,7 @@
           <a:bodyPr wrap="square" rtlCol="0" anchor="t"/>
           <a:lstStyle/>
           <a:p>
-            <a:pPr indent="0" marL="0">
+            <a:pPr marL="0" indent="0">
               <a:buNone/>
             </a:pPr>
             <a:r>
@@ -5824,7 +6081,7 @@
           <a:bodyPr wrap="square" lIns="0" tIns="0" rIns="0" bIns="0" rtlCol="0" anchor="ctr"/>
           <a:lstStyle/>
           <a:p>
-            <a:pPr algn="l" indent="0" marL="0">
+            <a:pPr marL="0" indent="0" algn="l">
               <a:buNone/>
             </a:pPr>
             <a:r>
@@ -5863,7 +6120,7 @@
           <a:bodyPr wrap="square" rtlCol="0" anchor="ctr"/>
           <a:lstStyle/>
           <a:p>
-            <a:pPr algn="r" indent="0" marL="0">
+            <a:pPr marL="0" indent="0" algn="r">
               <a:buNone/>
             </a:pPr>
             <a:r>
@@ -5897,6 +6154,7 @@
         <a:solidFill>
           <a:srgbClr val="FFFFFF"/>
         </a:solidFill>
+        <a:effectLst/>
       </p:bgPr>
     </p:bg>
     <p:spTree>
@@ -5934,7 +6192,7 @@
           <a:bodyPr wrap="square" lIns="0" tIns="0" rIns="0" bIns="0" rtlCol="0" anchor="t"/>
           <a:lstStyle/>
           <a:p>
-            <a:pPr algn="l" indent="0" marL="0">
+            <a:pPr marL="0" indent="0" algn="l">
               <a:buNone/>
             </a:pPr>
             <a:r>
@@ -5974,26 +6232,33 @@
             <a:prstDash val="solid"/>
           </a:ln>
         </p:spPr>
+        <p:txBody>
+          <a:bodyPr/>
+          <a:lstStyle/>
+          <a:p>
+            <a:endParaRPr lang="zh-CN" altLang="en-US"/>
+          </a:p>
+        </p:txBody>
       </p:sp>
       <p:pic>
         <p:nvPicPr>
-          <p:cNvPr id="3" name="Media 0">
+          <p:cNvPr id="4" name="Media 0">
             <a:hlinkClick r:id="" action="ppaction://media"/>
           </p:cNvPr>
           <p:cNvPicPr>
             <a:picLocks noChangeAspect="1"/>
           </p:cNvPicPr>
           <p:nvPr>
-            <a:videoFile r:link="rId1"/>
+            <a:videoFile r:link="rId2"/>
             <p:extLst>
               <p:ext uri="{DAA4B4D4-6D71-4841-9C94-3DE7FCFB9230}">
-                <p14:media xmlns:p14="http://schemas.microsoft.com/office/powerpoint/2010/main" r:embed="rId2"/>
+                <p14:media xmlns:p14="http://schemas.microsoft.com/office/powerpoint/2010/main" r:embed="rId1"/>
               </p:ext>
             </p:extLst>
           </p:nvPr>
         </p:nvPicPr>
         <p:blipFill>
-          <a:blip r:embed="rId3"/>
+          <a:blip r:embed="rId5"/>
           <a:stretch>
             <a:fillRect/>
           </a:stretch>
@@ -6029,7 +6294,7 @@
           <a:bodyPr wrap="square" rtlCol="0" anchor="ctr"/>
           <a:lstStyle/>
           <a:p>
-            <a:pPr indent="0" marL="0">
+            <a:pPr marL="0" indent="0">
               <a:buNone/>
             </a:pPr>
             <a:r>
@@ -6068,7 +6333,7 @@
           <a:bodyPr wrap="square" rtlCol="0" anchor="t"/>
           <a:lstStyle/>
           <a:p>
-            <a:pPr indent="0" marL="0">
+            <a:pPr marL="0" indent="0">
               <a:buNone/>
             </a:pPr>
             <a:r>
@@ -6085,7 +6350,7 @@
             <a:endParaRPr lang="en-US" sz="1150" dirty="0"/>
           </a:p>
           <a:p>
-            <a:pPr indent="0" marL="0">
+            <a:pPr marL="0" indent="0">
               <a:buNone/>
             </a:pPr>
             <a:r>
@@ -6102,7 +6367,7 @@
             <a:endParaRPr lang="en-US" sz="1150" dirty="0"/>
           </a:p>
           <a:p>
-            <a:pPr indent="0" marL="0">
+            <a:pPr marL="0" indent="0">
               <a:buNone/>
             </a:pPr>
             <a:r>
@@ -6119,7 +6384,7 @@
             <a:endParaRPr lang="en-US" sz="1150" dirty="0"/>
           </a:p>
           <a:p>
-            <a:pPr indent="0" marL="0">
+            <a:pPr marL="0" indent="0">
               <a:buNone/>
             </a:pPr>
             <a:r>
@@ -6136,7 +6401,7 @@
             <a:endParaRPr lang="en-US" sz="1150" dirty="0"/>
           </a:p>
           <a:p>
-            <a:pPr indent="0" marL="0">
+            <a:pPr marL="0" indent="0">
               <a:buNone/>
             </a:pPr>
             <a:r>
@@ -6153,7 +6418,7 @@
             <a:endParaRPr lang="en-US" sz="1150" dirty="0"/>
           </a:p>
           <a:p>
-            <a:pPr indent="0" marL="0">
+            <a:pPr marL="0" indent="0">
               <a:buNone/>
             </a:pPr>
             <a:r>
@@ -6179,7 +6444,7 @@
         </p:nvSpPr>
         <p:spPr>
           <a:xfrm>
-            <a:off x="5760720" y="3017520"/>
+            <a:off x="5760720" y="2852992"/>
             <a:ext cx="3108960" cy="1280160"/>
           </a:xfrm>
           <a:prstGeom prst="rect">
@@ -6195,6 +6460,13 @@
             <a:prstDash val="solid"/>
           </a:ln>
         </p:spPr>
+        <p:txBody>
+          <a:bodyPr/>
+          <a:lstStyle/>
+          <a:p>
+            <a:endParaRPr lang="zh-CN" altLang="en-US"/>
+          </a:p>
+        </p:txBody>
       </p:sp>
       <p:sp>
         <p:nvSpPr>
@@ -6204,7 +6476,7 @@
         </p:nvSpPr>
         <p:spPr>
           <a:xfrm>
-            <a:off x="5897880" y="3063240"/>
+            <a:off x="5897880" y="2898712"/>
             <a:ext cx="2834640" cy="256032"/>
           </a:xfrm>
           <a:prstGeom prst="rect">
@@ -6217,11 +6489,11 @@
           <a:bodyPr wrap="square" lIns="0" tIns="0" rIns="0" bIns="0" rtlCol="0" anchor="ctr"/>
           <a:lstStyle/>
           <a:p>
-            <a:pPr indent="0" marL="0">
-              <a:buNone/>
-            </a:pPr>
-            <a:r>
-              <a:rPr lang="en-US" sz="1000" b="1" spc="300" kern="0" dirty="0">
+            <a:pPr marL="0" indent="0">
+              <a:buNone/>
+            </a:pPr>
+            <a:r>
+              <a:rPr lang="en-US" sz="1000" b="1" kern="0" spc="300" dirty="0">
                 <a:solidFill>
                   <a:srgbClr val="5A8A99"/>
                 </a:solidFill>
@@ -6243,7 +6515,7 @@
         </p:nvSpPr>
         <p:spPr>
           <a:xfrm>
-            <a:off x="5897880" y="3337560"/>
+            <a:off x="5897880" y="3173032"/>
             <a:ext cx="2834640" cy="502920"/>
           </a:xfrm>
           <a:prstGeom prst="rect">
@@ -6256,7 +6528,7 @@
           <a:bodyPr wrap="square" lIns="0" tIns="0" rIns="0" bIns="0" rtlCol="0" anchor="ctr"/>
           <a:lstStyle/>
           <a:p>
-            <a:pPr indent="0" marL="0">
+            <a:pPr marL="0" indent="0">
               <a:buNone/>
             </a:pPr>
             <a:r>
@@ -6282,7 +6554,7 @@
         </p:nvSpPr>
         <p:spPr>
           <a:xfrm>
-            <a:off x="5897880" y="3840480"/>
+            <a:off x="5897880" y="3675952"/>
             <a:ext cx="2834640" cy="274320"/>
           </a:xfrm>
           <a:prstGeom prst="rect">
@@ -6295,7 +6567,7 @@
           <a:bodyPr wrap="square" lIns="0" tIns="0" rIns="0" bIns="0" rtlCol="0" anchor="ctr"/>
           <a:lstStyle/>
           <a:p>
-            <a:pPr indent="0" marL="0">
+            <a:pPr marL="0" indent="0">
               <a:buNone/>
             </a:pPr>
             <a:r>
@@ -6334,7 +6606,7 @@
           <a:bodyPr wrap="square" lIns="0" tIns="0" rIns="0" bIns="0" rtlCol="0" anchor="ctr"/>
           <a:lstStyle/>
           <a:p>
-            <a:pPr indent="0" marL="0">
+            <a:pPr marL="0" indent="0">
               <a:buNone/>
             </a:pPr>
             <a:r>
@@ -6373,7 +6645,7 @@
           <a:bodyPr wrap="square" lIns="0" tIns="0" rIns="0" bIns="0" rtlCol="0" anchor="ctr"/>
           <a:lstStyle/>
           <a:p>
-            <a:pPr algn="l" indent="0" marL="0">
+            <a:pPr marL="0" indent="0" algn="l">
               <a:buNone/>
             </a:pPr>
             <a:r>
@@ -6412,7 +6684,7 @@
           <a:bodyPr wrap="square" rtlCol="0" anchor="ctr"/>
           <a:lstStyle/>
           <a:p>
-            <a:pPr algn="r" indent="0" marL="0">
+            <a:pPr marL="0" indent="0" algn="r">
               <a:buNone/>
             </a:pPr>
             <a:r>
@@ -6446,6 +6718,7 @@
         <a:solidFill>
           <a:srgbClr val="1F2937"/>
         </a:solidFill>
+        <a:effectLst/>
       </p:bgPr>
     </p:bg>
     <p:spTree>
@@ -6483,7 +6756,7 @@
           <a:bodyPr wrap="square" lIns="0" tIns="0" rIns="0" bIns="0" rtlCol="0" anchor="ctr"/>
           <a:lstStyle/>
           <a:p>
-            <a:pPr indent="0" marL="0">
+            <a:pPr marL="0" indent="0">
               <a:buNone/>
             </a:pPr>
             <a:r>
@@ -6523,6 +6796,13 @@
             <a:prstDash val="solid"/>
           </a:ln>
         </p:spPr>
+        <p:txBody>
+          <a:bodyPr/>
+          <a:lstStyle/>
+          <a:p>
+            <a:endParaRPr lang="zh-CN" altLang="en-US"/>
+          </a:p>
+        </p:txBody>
       </p:sp>
       <p:sp>
         <p:nvSpPr>
@@ -6545,7 +6825,7 @@
           <a:bodyPr wrap="square" lIns="0" tIns="0" rIns="0" bIns="0" rtlCol="0" anchor="ctr"/>
           <a:lstStyle/>
           <a:p>
-            <a:pPr indent="0" marL="0">
+            <a:pPr marL="0" indent="0">
               <a:buNone/>
             </a:pPr>
             <a:r>
@@ -6584,11 +6864,11 @@
           <a:bodyPr wrap="square" lIns="0" tIns="0" rIns="0" bIns="0" rtlCol="0" anchor="ctr"/>
           <a:lstStyle/>
           <a:p>
-            <a:pPr indent="0" marL="0">
-              <a:buNone/>
-            </a:pPr>
-            <a:r>
-              <a:rPr lang="en-US" sz="1400" b="1" spc="100" kern="0" dirty="0">
+            <a:pPr marL="0" indent="0">
+              <a:buNone/>
+            </a:pPr>
+            <a:r>
+              <a:rPr lang="en-US" sz="1400" b="1" kern="0" spc="100" dirty="0">
                 <a:solidFill>
                   <a:srgbClr val="FFFFFF"/>
                 </a:solidFill>
@@ -6708,11 +6988,11 @@
           <a:bodyPr wrap="square" lIns="0" tIns="0" rIns="0" bIns="0" rtlCol="0" anchor="ctr"/>
           <a:lstStyle/>
           <a:p>
-            <a:pPr indent="0" marL="0">
-              <a:buNone/>
-            </a:pPr>
-            <a:r>
-              <a:rPr lang="en-US" sz="1400" b="1" spc="100" kern="0" dirty="0">
+            <a:pPr marL="0" indent="0">
+              <a:buNone/>
+            </a:pPr>
+            <a:r>
+              <a:rPr lang="en-US" sz="1400" b="1" kern="0" spc="100" dirty="0">
                 <a:solidFill>
                   <a:srgbClr val="FFFFFF"/>
                 </a:solidFill>
@@ -6832,7 +7112,7 @@
           <a:bodyPr wrap="square" lIns="0" tIns="0" rIns="0" bIns="0" rtlCol="0" anchor="ctr"/>
           <a:lstStyle/>
           <a:p>
-            <a:pPr indent="0" marL="0">
+            <a:pPr marL="0" indent="0">
               <a:buNone/>
             </a:pPr>
             <a:r>
@@ -6871,7 +7151,7 @@
           <a:bodyPr wrap="square" lIns="0" tIns="0" rIns="0" bIns="0" rtlCol="0" anchor="ctr"/>
           <a:lstStyle/>
           <a:p>
-            <a:pPr algn="r" indent="0" marL="0">
+            <a:pPr marL="0" indent="0" algn="r">
               <a:buNone/>
             </a:pPr>
             <a:r>
@@ -7190,4 +7470,319 @@
     </a:ext>
   </a:extLst>
 </a:theme>
+</file>
+
+<file path=ppt/theme/theme2.xml><?xml version="1.0" encoding="utf-8"?>
+<a:theme xmlns:a="http://schemas.openxmlformats.org/drawingml/2006/main" name="Office 主题​​">
+  <a:themeElements>
+    <a:clrScheme name="Office">
+      <a:dk1>
+        <a:sysClr val="windowText" lastClr="000000"/>
+      </a:dk1>
+      <a:lt1>
+        <a:sysClr val="window" lastClr="FFFFFF"/>
+      </a:lt1>
+      <a:dk2>
+        <a:srgbClr val="0E2841"/>
+      </a:dk2>
+      <a:lt2>
+        <a:srgbClr val="E8E8E8"/>
+      </a:lt2>
+      <a:accent1>
+        <a:srgbClr val="156082"/>
+      </a:accent1>
+      <a:accent2>
+        <a:srgbClr val="E97132"/>
+      </a:accent2>
+      <a:accent3>
+        <a:srgbClr val="196B24"/>
+      </a:accent3>
+      <a:accent4>
+        <a:srgbClr val="0F9ED5"/>
+      </a:accent4>
+      <a:accent5>
+        <a:srgbClr val="A02B93"/>
+      </a:accent5>
+      <a:accent6>
+        <a:srgbClr val="4EA72E"/>
+      </a:accent6>
+      <a:hlink>
+        <a:srgbClr val="467886"/>
+      </a:hlink>
+      <a:folHlink>
+        <a:srgbClr val="96607D"/>
+      </a:folHlink>
+    </a:clrScheme>
+    <a:fontScheme name="Office">
+      <a:majorFont>
+        <a:latin typeface="等线 Light" panose="02110004020202020204"/>
+        <a:ea typeface=""/>
+        <a:cs typeface=""/>
+        <a:font script="Jpan" typeface="游ゴシック Light"/>
+        <a:font script="Hang" typeface="맑은 고딕"/>
+        <a:font script="Hans" typeface="等线 Light"/>
+        <a:font script="Hant" typeface="新細明體"/>
+        <a:font script="Arab" typeface="Times New Roman"/>
+        <a:font script="Hebr" typeface="Times New Roman"/>
+        <a:font script="Thai" typeface="Angsana New"/>
+        <a:font script="Ethi" typeface="Nyala"/>
+        <a:font script="Beng" typeface="Vrinda"/>
+        <a:font script="Gujr" typeface="Shruti"/>
+        <a:font script="Khmr" typeface="MoolBoran"/>
+        <a:font script="Knda" typeface="Tunga"/>
+        <a:font script="Guru" typeface="Raavi"/>
+        <a:font script="Cans" typeface="Euphemia"/>
+        <a:font script="Cher" typeface="Plantagenet Cherokee"/>
+        <a:font script="Yiii" typeface="Microsoft Yi Baiti"/>
+        <a:font script="Tibt" typeface="Microsoft Himalaya"/>
+        <a:font script="Thaa" typeface="MV Boli"/>
+        <a:font script="Deva" typeface="Mangal"/>
+        <a:font script="Telu" typeface="Gautami"/>
+        <a:font script="Taml" typeface="Latha"/>
+        <a:font script="Syrc" typeface="Estrangelo Edessa"/>
+        <a:font script="Orya" typeface="Kalinga"/>
+        <a:font script="Mlym" typeface="Kartika"/>
+        <a:font script="Laoo" typeface="DokChampa"/>
+        <a:font script="Sinh" typeface="Iskoola Pota"/>
+        <a:font script="Mong" typeface="Mongolian Baiti"/>
+        <a:font script="Viet" typeface="Times New Roman"/>
+        <a:font script="Uigh" typeface="Microsoft Uighur"/>
+        <a:font script="Geor" typeface="Sylfaen"/>
+        <a:font script="Armn" typeface="Arial"/>
+        <a:font script="Bugi" typeface="Leelawadee UI"/>
+        <a:font script="Bopo" typeface="Microsoft JhengHei"/>
+        <a:font script="Java" typeface="Javanese Text"/>
+        <a:font script="Lisu" typeface="Segoe UI"/>
+        <a:font script="Mymr" typeface="Myanmar Text"/>
+        <a:font script="Nkoo" typeface="Ebrima"/>
+        <a:font script="Olck" typeface="Nirmala UI"/>
+        <a:font script="Osma" typeface="Ebrima"/>
+        <a:font script="Phag" typeface="Phagspa"/>
+        <a:font script="Syrn" typeface="Estrangelo Edessa"/>
+        <a:font script="Syrj" typeface="Estrangelo Edessa"/>
+        <a:font script="Syre" typeface="Estrangelo Edessa"/>
+        <a:font script="Sora" typeface="Nirmala UI"/>
+        <a:font script="Tale" typeface="Microsoft Tai Le"/>
+        <a:font script="Talu" typeface="Microsoft New Tai Lue"/>
+        <a:font script="Tfng" typeface="Ebrima"/>
+      </a:majorFont>
+      <a:minorFont>
+        <a:latin typeface="等线" panose="02110004020202020204"/>
+        <a:ea typeface=""/>
+        <a:cs typeface=""/>
+        <a:font script="Jpan" typeface="游ゴシック"/>
+        <a:font script="Hang" typeface="맑은 고딕"/>
+        <a:font script="Hans" typeface="等线"/>
+        <a:font script="Hant" typeface="新細明體"/>
+        <a:font script="Arab" typeface="Arial"/>
+        <a:font script="Hebr" typeface="Arial"/>
+        <a:font script="Thai" typeface="Cordia New"/>
+        <a:font script="Ethi" typeface="Nyala"/>
+        <a:font script="Beng" typeface="Vrinda"/>
+        <a:font script="Gujr" typeface="Shruti"/>
+        <a:font script="Khmr" typeface="DaunPenh"/>
+        <a:font script="Knda" typeface="Tunga"/>
+        <a:font script="Guru" typeface="Raavi"/>
+        <a:font script="Cans" typeface="Euphemia"/>
+        <a:font script="Cher" typeface="Plantagenet Cherokee"/>
+        <a:font script="Yiii" typeface="Microsoft Yi Baiti"/>
+        <a:font script="Tibt" typeface="Microsoft Himalaya"/>
+        <a:font script="Thaa" typeface="MV Boli"/>
+        <a:font script="Deva" typeface="Mangal"/>
+        <a:font script="Telu" typeface="Gautami"/>
+        <a:font script="Taml" typeface="Latha"/>
+        <a:font script="Syrc" typeface="Estrangelo Edessa"/>
+        <a:font script="Orya" typeface="Kalinga"/>
+        <a:font script="Mlym" typeface="Kartika"/>
+        <a:font script="Laoo" typeface="DokChampa"/>
+        <a:font script="Sinh" typeface="Iskoola Pota"/>
+        <a:font script="Mong" typeface="Mongolian Baiti"/>
+        <a:font script="Viet" typeface="Arial"/>
+        <a:font script="Uigh" typeface="Microsoft Uighur"/>
+        <a:font script="Geor" typeface="Sylfaen"/>
+        <a:font script="Armn" typeface="Arial"/>
+        <a:font script="Bugi" typeface="Leelawadee UI"/>
+        <a:font script="Bopo" typeface="Microsoft JhengHei"/>
+        <a:font script="Java" typeface="Javanese Text"/>
+        <a:font script="Lisu" typeface="Segoe UI"/>
+        <a:font script="Mymr" typeface="Myanmar Text"/>
+        <a:font script="Nkoo" typeface="Ebrima"/>
+        <a:font script="Olck" typeface="Nirmala UI"/>
+        <a:font script="Osma" typeface="Ebrima"/>
+        <a:font script="Phag" typeface="Phagspa"/>
+        <a:font script="Syrn" typeface="Estrangelo Edessa"/>
+        <a:font script="Syrj" typeface="Estrangelo Edessa"/>
+        <a:font script="Syre" typeface="Estrangelo Edessa"/>
+        <a:font script="Sora" typeface="Nirmala UI"/>
+        <a:font script="Tale" typeface="Microsoft Tai Le"/>
+        <a:font script="Talu" typeface="Microsoft New Tai Lue"/>
+        <a:font script="Tfng" typeface="Ebrima"/>
+      </a:minorFont>
+    </a:fontScheme>
+    <a:fmtScheme name="Office">
+      <a:fillStyleLst>
+        <a:solidFill>
+          <a:schemeClr val="phClr"/>
+        </a:solidFill>
+        <a:gradFill rotWithShape="1">
+          <a:gsLst>
+            <a:gs pos="0">
+              <a:schemeClr val="phClr">
+                <a:lumMod val="110000"/>
+                <a:satMod val="105000"/>
+                <a:tint val="67000"/>
+              </a:schemeClr>
+            </a:gs>
+            <a:gs pos="50000">
+              <a:schemeClr val="phClr">
+                <a:lumMod val="105000"/>
+                <a:satMod val="103000"/>
+                <a:tint val="73000"/>
+              </a:schemeClr>
+            </a:gs>
+            <a:gs pos="100000">
+              <a:schemeClr val="phClr">
+                <a:lumMod val="105000"/>
+                <a:satMod val="109000"/>
+                <a:tint val="81000"/>
+              </a:schemeClr>
+            </a:gs>
+          </a:gsLst>
+          <a:lin ang="5400000" scaled="0"/>
+        </a:gradFill>
+        <a:gradFill rotWithShape="1">
+          <a:gsLst>
+            <a:gs pos="0">
+              <a:schemeClr val="phClr">
+                <a:satMod val="103000"/>
+                <a:lumMod val="102000"/>
+                <a:tint val="94000"/>
+              </a:schemeClr>
+            </a:gs>
+            <a:gs pos="50000">
+              <a:schemeClr val="phClr">
+                <a:satMod val="110000"/>
+                <a:lumMod val="100000"/>
+                <a:shade val="100000"/>
+              </a:schemeClr>
+            </a:gs>
+            <a:gs pos="100000">
+              <a:schemeClr val="phClr">
+                <a:lumMod val="99000"/>
+                <a:satMod val="120000"/>
+                <a:shade val="78000"/>
+              </a:schemeClr>
+            </a:gs>
+          </a:gsLst>
+          <a:lin ang="5400000" scaled="0"/>
+        </a:gradFill>
+      </a:fillStyleLst>
+      <a:lnStyleLst>
+        <a:ln w="12700" cap="flat" cmpd="sng" algn="ctr">
+          <a:solidFill>
+            <a:schemeClr val="phClr"/>
+          </a:solidFill>
+          <a:prstDash val="solid"/>
+          <a:miter lim="800000"/>
+        </a:ln>
+        <a:ln w="19050" cap="flat" cmpd="sng" algn="ctr">
+          <a:solidFill>
+            <a:schemeClr val="phClr"/>
+          </a:solidFill>
+          <a:prstDash val="solid"/>
+          <a:miter lim="800000"/>
+        </a:ln>
+        <a:ln w="25400" cap="flat" cmpd="sng" algn="ctr">
+          <a:solidFill>
+            <a:schemeClr val="phClr"/>
+          </a:solidFill>
+          <a:prstDash val="solid"/>
+          <a:miter lim="800000"/>
+        </a:ln>
+      </a:lnStyleLst>
+      <a:effectStyleLst>
+        <a:effectStyle>
+          <a:effectLst/>
+        </a:effectStyle>
+        <a:effectStyle>
+          <a:effectLst/>
+        </a:effectStyle>
+        <a:effectStyle>
+          <a:effectLst>
+            <a:outerShdw blurRad="57150" dist="19050" dir="5400000" algn="ctr" rotWithShape="0">
+              <a:srgbClr val="000000">
+                <a:alpha val="63000"/>
+              </a:srgbClr>
+            </a:outerShdw>
+          </a:effectLst>
+        </a:effectStyle>
+      </a:effectStyleLst>
+      <a:bgFillStyleLst>
+        <a:solidFill>
+          <a:schemeClr val="phClr"/>
+        </a:solidFill>
+        <a:solidFill>
+          <a:schemeClr val="phClr">
+            <a:tint val="95000"/>
+            <a:satMod val="170000"/>
+          </a:schemeClr>
+        </a:solidFill>
+        <a:gradFill rotWithShape="1">
+          <a:gsLst>
+            <a:gs pos="0">
+              <a:schemeClr val="phClr">
+                <a:tint val="93000"/>
+                <a:satMod val="150000"/>
+                <a:shade val="98000"/>
+                <a:lumMod val="102000"/>
+              </a:schemeClr>
+            </a:gs>
+            <a:gs pos="50000">
+              <a:schemeClr val="phClr">
+                <a:tint val="98000"/>
+                <a:satMod val="130000"/>
+                <a:shade val="90000"/>
+                <a:lumMod val="103000"/>
+              </a:schemeClr>
+            </a:gs>
+            <a:gs pos="100000">
+              <a:schemeClr val="phClr">
+                <a:shade val="63000"/>
+                <a:satMod val="120000"/>
+              </a:schemeClr>
+            </a:gs>
+          </a:gsLst>
+          <a:lin ang="5400000" scaled="0"/>
+        </a:gradFill>
+      </a:bgFillStyleLst>
+    </a:fmtScheme>
+  </a:themeElements>
+  <a:objectDefaults>
+    <a:lnDef>
+      <a:spPr/>
+      <a:bodyPr/>
+      <a:lstStyle/>
+      <a:style>
+        <a:lnRef idx="2">
+          <a:schemeClr val="accent1"/>
+        </a:lnRef>
+        <a:fillRef idx="0">
+          <a:schemeClr val="accent1"/>
+        </a:fillRef>
+        <a:effectRef idx="1">
+          <a:schemeClr val="accent1"/>
+        </a:effectRef>
+        <a:fontRef idx="minor">
+          <a:schemeClr val="tx1"/>
+        </a:fontRef>
+      </a:style>
+    </a:lnDef>
+  </a:objectDefaults>
+  <a:extraClrSchemeLst/>
+  <a:extLst>
+    <a:ext uri="{05A4C25C-085E-4340-85A3-A5531E510DB2}">
+      <thm15:themeFamily xmlns:thm15="http://schemas.microsoft.com/office/thememl/2012/main" name="Office Theme" id="{2E142A2C-CD16-42D6-873A-C26D2A0506FA}" vid="{1BDDFF52-6CD6-40A5-AB3C-68EB2F1E4D0A}"/>
+    </a:ext>
+  </a:extLst>
+</a:theme>
 </file>
</xml_diff>